<commit_message>
Restyle training slides with Spain theme
</commit_message>
<xml_diff>
--- a/assets/NTW-2026-Agentic-AI-Pembukaan-10-Minit.pptx
+++ b/assets/NTW-2026-Agentic-AI-Pembukaan-10-Minit.pptx
@@ -2,19 +2,19 @@
 <file path=ppt/presentation.xml><?xml version="1.0" encoding="utf-8"?>
 <p:presentation xmlns:p="http://schemas.openxmlformats.org/presentationml/2006/main">
   <p:sldMasterIdLst>
-    <p:sldMasterId xmlns:r="http://schemas.openxmlformats.org/officeDocument/2006/relationships" id="2147483648" r:id="R2baf03d57f044493"/>
+    <p:sldMasterId xmlns:r="http://schemas.openxmlformats.org/officeDocument/2006/relationships" id="2147483648" r:id="R78049ea1f5104de9"/>
   </p:sldMasterIdLst>
   <p:notesMasterIdLst>
-    <p:notesMasterId xmlns:r="http://schemas.openxmlformats.org/officeDocument/2006/relationships" r:id="Rc896c66cc2e54c43"/>
+    <p:notesMasterId xmlns:r="http://schemas.openxmlformats.org/officeDocument/2006/relationships" r:id="R714fa0ba4e4a4792"/>
   </p:notesMasterIdLst>
   <p:sldIdLst>
-    <p:sldId xmlns:r="http://schemas.openxmlformats.org/officeDocument/2006/relationships" id="256" r:id="R96455833dabd4fdf"/>
-    <p:sldId xmlns:r="http://schemas.openxmlformats.org/officeDocument/2006/relationships" id="257" r:id="R7e503c8fa1694469"/>
-    <p:sldId xmlns:r="http://schemas.openxmlformats.org/officeDocument/2006/relationships" id="258" r:id="R31833ba72e1e4020"/>
-    <p:sldId xmlns:r="http://schemas.openxmlformats.org/officeDocument/2006/relationships" id="259" r:id="Rc84a32b6f5d146b4"/>
-    <p:sldId xmlns:r="http://schemas.openxmlformats.org/officeDocument/2006/relationships" id="260" r:id="R85ef29d0108947c6"/>
-    <p:sldId xmlns:r="http://schemas.openxmlformats.org/officeDocument/2006/relationships" id="261" r:id="R7beabd0d104c4014"/>
-    <p:sldId xmlns:r="http://schemas.openxmlformats.org/officeDocument/2006/relationships" id="262" r:id="Rc7245281b94e4d42"/>
+    <p:sldId xmlns:r="http://schemas.openxmlformats.org/officeDocument/2006/relationships" id="256" r:id="R7055f588a92e460f"/>
+    <p:sldId xmlns:r="http://schemas.openxmlformats.org/officeDocument/2006/relationships" id="257" r:id="R9a17b25843de4c88"/>
+    <p:sldId xmlns:r="http://schemas.openxmlformats.org/officeDocument/2006/relationships" id="258" r:id="R631d93e08df94177"/>
+    <p:sldId xmlns:r="http://schemas.openxmlformats.org/officeDocument/2006/relationships" id="259" r:id="R8c539546564b4548"/>
+    <p:sldId xmlns:r="http://schemas.openxmlformats.org/officeDocument/2006/relationships" id="260" r:id="R3ca1450e4af546fc"/>
+    <p:sldId xmlns:r="http://schemas.openxmlformats.org/officeDocument/2006/relationships" id="261" r:id="Rf2abac0d238e4f98"/>
+    <p:sldId xmlns:r="http://schemas.openxmlformats.org/officeDocument/2006/relationships" id="262" r:id="R769c95d7422444ca"/>
   </p:sldIdLst>
   <p:sldSz cx="12192000" cy="6858000"/>
   <p:notesSz cx="6858000" cy="9144000"/>
@@ -263,40 +263,40 @@
   <a:themeElements>
     <a:clrScheme name="ChatGPT">
       <a:dk1>
-        <a:srgbClr val="000000"/>
+        <a:srgbClr val="2C070A"/>
       </a:dk1>
       <a:lt1>
-        <a:srgbClr val="FFFFFF"/>
+        <a:srgbClr val="FFF8E7"/>
       </a:lt1>
       <a:dk2>
-        <a:srgbClr val="0E2841"/>
+        <a:srgbClr val="4A0B10"/>
       </a:dk2>
       <a:lt2>
-        <a:srgbClr val="E8E8E8"/>
+        <a:srgbClr val="F4E4B4"/>
       </a:lt2>
       <a:accent1>
-        <a:srgbClr val="156082"/>
+        <a:srgbClr val="AA151B"/>
       </a:accent1>
       <a:accent2>
-        <a:srgbClr val="E97132"/>
+        <a:srgbClr val="F1BF00"/>
       </a:accent2>
       <a:accent3>
-        <a:srgbClr val="196B24"/>
+        <a:srgbClr val="7E1418"/>
       </a:accent3>
       <a:accent4>
-        <a:srgbClr val="0F9ED5"/>
+        <a:srgbClr val="C62828"/>
       </a:accent4>
       <a:accent5>
-        <a:srgbClr val="A02B93"/>
+        <a:srgbClr val="8A1C24"/>
       </a:accent5>
       <a:accent6>
-        <a:srgbClr val="4EA72E"/>
+        <a:srgbClr val="D89E00"/>
       </a:accent6>
       <a:hlink>
-        <a:srgbClr val="467886"/>
+        <a:srgbClr val="AA151B"/>
       </a:hlink>
       <a:folHlink>
-        <a:srgbClr val="96607D"/>
+        <a:srgbClr val="8A1C24"/>
       </a:folHlink>
     </a:clrScheme>
     <a:fontScheme name="Office">
@@ -399,7 +399,7 @@
         <a:effectStyle>
           <a:effectLst>
             <a:outerShdw blurRad="57150" dist="19050" dir="5400000">
-              <a:srgbClr val="000000">
+              <a:srgbClr val="2C070A">
                 <a:alpha val="16000"/>
               </a:srgbClr>
             </a:outerShdw>
@@ -408,7 +408,7 @@
         <a:effectStyle>
           <a:effectLst>
             <a:outerShdw blurRad="19050" dist="9525" dir="5400000">
-              <a:srgbClr val="000000">
+              <a:srgbClr val="2C070A">
                 <a:alpha val="6000"/>
               </a:srgbClr>
             </a:outerShdw>
@@ -417,7 +417,7 @@
         <a:effectStyle>
           <a:effectLst>
             <a:outerShdw blurRad="28575" dist="9525" dir="5400000">
-              <a:srgbClr val="000000">
+              <a:srgbClr val="2C070A">
                 <a:alpha val="8000"/>
               </a:srgbClr>
             </a:outerShdw>
@@ -426,7 +426,7 @@
         <a:effectStyle>
           <a:effectLst>
             <a:outerShdw blurRad="57150" dist="19050" dir="5400000">
-              <a:srgbClr val="000000">
+              <a:srgbClr val="2C070A">
                 <a:alpha val="10000"/>
               </a:srgbClr>
             </a:outerShdw>
@@ -435,7 +435,7 @@
         <a:effectStyle>
           <a:effectLst>
             <a:outerShdw blurRad="114300" dist="38100" dir="5400000">
-              <a:srgbClr val="000000">
+              <a:srgbClr val="2C070A">
                 <a:alpha val="12000"/>
               </a:srgbClr>
             </a:outerShdw>
@@ -444,7 +444,7 @@
         <a:effectStyle>
           <a:effectLst>
             <a:outerShdw blurRad="171450" dist="57150" dir="5400000">
-              <a:srgbClr val="000000">
+              <a:srgbClr val="2C070A">
                 <a:alpha val="16000"/>
               </a:srgbClr>
             </a:outerShdw>
@@ -453,7 +453,7 @@
         <a:effectStyle>
           <a:effectLst>
             <a:outerShdw blurRad="266700" dist="95250" dir="5400000">
-              <a:srgbClr val="000000">
+              <a:srgbClr val="2C070A">
                 <a:alpha val="24000"/>
               </a:srgbClr>
             </a:outerShdw>
@@ -1003,7 +1003,7 @@
   </p:cSld>
   <p:clrMap bg1="lt1" tx1="dk1" bg2="lt2" tx2="dk2" accent1="accent1" accent2="accent2" accent3="accent3" accent4="accent4" accent5="accent5" accent6="accent6" hlink="hlink" folHlink="folHlink"/>
   <p:sldLayoutIdLst>
-    <p:sldLayoutId xmlns:r="http://schemas.openxmlformats.org/officeDocument/2006/relationships" id="2147483649" r:id="R6bacf5611cee4bc2"/>
+    <p:sldLayoutId xmlns:r="http://schemas.openxmlformats.org/officeDocument/2006/relationships" id="2147483649" r:id="R9ff4c738b0564c45"/>
   </p:sldLayoutIdLst>
   <p:txStyles>
     <p:titleStyle>
@@ -1290,40 +1290,40 @@
   <a:themeElements>
     <a:clrScheme name="ChatGPT">
       <a:dk1>
-        <a:srgbClr val="000000"/>
+        <a:srgbClr val="2C070A"/>
       </a:dk1>
       <a:lt1>
-        <a:srgbClr val="FFFFFF"/>
+        <a:srgbClr val="FFF8E7"/>
       </a:lt1>
       <a:dk2>
-        <a:srgbClr val="0E2841"/>
+        <a:srgbClr val="4A0B10"/>
       </a:dk2>
       <a:lt2>
-        <a:srgbClr val="E8E8E8"/>
+        <a:srgbClr val="F4E4B4"/>
       </a:lt2>
       <a:accent1>
-        <a:srgbClr val="156082"/>
+        <a:srgbClr val="AA151B"/>
       </a:accent1>
       <a:accent2>
-        <a:srgbClr val="E97132"/>
+        <a:srgbClr val="F1BF00"/>
       </a:accent2>
       <a:accent3>
-        <a:srgbClr val="196B24"/>
+        <a:srgbClr val="7E1418"/>
       </a:accent3>
       <a:accent4>
-        <a:srgbClr val="0F9ED5"/>
+        <a:srgbClr val="C62828"/>
       </a:accent4>
       <a:accent5>
-        <a:srgbClr val="A02B93"/>
+        <a:srgbClr val="8A1C24"/>
       </a:accent5>
       <a:accent6>
-        <a:srgbClr val="4EA72E"/>
+        <a:srgbClr val="D89E00"/>
       </a:accent6>
       <a:hlink>
-        <a:srgbClr val="467886"/>
+        <a:srgbClr val="AA151B"/>
       </a:hlink>
       <a:folHlink>
-        <a:srgbClr val="96607D"/>
+        <a:srgbClr val="8A1C24"/>
       </a:folHlink>
     </a:clrScheme>
     <a:fontScheme name="Office">
@@ -1426,7 +1426,7 @@
         <a:effectStyle>
           <a:effectLst>
             <a:outerShdw blurRad="57150" dist="19050" dir="5400000">
-              <a:srgbClr val="000000">
+              <a:srgbClr val="2C070A">
                 <a:alpha val="16000"/>
               </a:srgbClr>
             </a:outerShdw>
@@ -1435,7 +1435,7 @@
         <a:effectStyle>
           <a:effectLst>
             <a:outerShdw blurRad="19050" dist="9525" dir="5400000">
-              <a:srgbClr val="000000">
+              <a:srgbClr val="2C070A">
                 <a:alpha val="6000"/>
               </a:srgbClr>
             </a:outerShdw>
@@ -1444,7 +1444,7 @@
         <a:effectStyle>
           <a:effectLst>
             <a:outerShdw blurRad="28575" dist="9525" dir="5400000">
-              <a:srgbClr val="000000">
+              <a:srgbClr val="2C070A">
                 <a:alpha val="8000"/>
               </a:srgbClr>
             </a:outerShdw>
@@ -1453,7 +1453,7 @@
         <a:effectStyle>
           <a:effectLst>
             <a:outerShdw blurRad="57150" dist="19050" dir="5400000">
-              <a:srgbClr val="000000">
+              <a:srgbClr val="2C070A">
                 <a:alpha val="10000"/>
               </a:srgbClr>
             </a:outerShdw>
@@ -1462,7 +1462,7 @@
         <a:effectStyle>
           <a:effectLst>
             <a:outerShdw blurRad="114300" dist="38100" dir="5400000">
-              <a:srgbClr val="000000">
+              <a:srgbClr val="2C070A">
                 <a:alpha val="12000"/>
               </a:srgbClr>
             </a:outerShdw>
@@ -1471,7 +1471,7 @@
         <a:effectStyle>
           <a:effectLst>
             <a:outerShdw blurRad="171450" dist="57150" dir="5400000">
-              <a:srgbClr val="000000">
+              <a:srgbClr val="2C070A">
                 <a:alpha val="16000"/>
               </a:srgbClr>
             </a:outerShdw>
@@ -1480,7 +1480,7 @@
         <a:effectStyle>
           <a:effectLst>
             <a:outerShdw blurRad="266700" dist="95250" dir="5400000">
-              <a:srgbClr val="000000">
+              <a:srgbClr val="2C070A">
                 <a:alpha val="24000"/>
               </a:srgbClr>
             </a:outerShdw>
@@ -1536,7 +1536,7 @@
     <p:bg>
       <p:bgPr>
         <a:solidFill xmlns:a="http://schemas.openxmlformats.org/drawingml/2006/main">
-          <a:srgbClr val="FFFFFF"/>
+          <a:srgbClr val="FFF8E7"/>
         </a:solidFill>
       </p:bgPr>
     </p:bg>
@@ -1582,16 +1582,17 @@
           <a:lstStyle xmlns:a="http://schemas.openxmlformats.org/drawingml/2006/main"/>
           <a:p xmlns:a="http://schemas.openxmlformats.org/drawingml/2006/main">
             <a:pPr algn="l">
+              <a:buNone/>
               <a:defRPr sz="1125" b="1">
                 <a:solidFill>
-                  <a:srgbClr val="536175"/>
+                  <a:srgbClr val="6F5550"/>
                 </a:solidFill>
               </a:defRPr>
             </a:pPr>
             <a:r>
               <a:rPr sz="1125" b="1">
                 <a:solidFill>
-                  <a:srgbClr val="536175"/>
+                  <a:srgbClr val="6F5550"/>
                 </a:solidFill>
               </a:rPr>
               <a:t>NTW 2026 · UTM</a:t>
@@ -1632,16 +1633,17 @@
           <a:lstStyle xmlns:a="http://schemas.openxmlformats.org/drawingml/2006/main"/>
           <a:p xmlns:a="http://schemas.openxmlformats.org/drawingml/2006/main">
             <a:pPr algn="l">
+              <a:buNone/>
               <a:defRPr sz="3900" b="1">
                 <a:solidFill>
-                  <a:srgbClr val="0B1628"/>
+                  <a:srgbClr val="4A0B10"/>
                 </a:solidFill>
               </a:defRPr>
             </a:pPr>
             <a:r>
               <a:rPr sz="3900" b="1">
                 <a:solidFill>
-                  <a:srgbClr val="0B1628"/>
+                  <a:srgbClr val="4A0B10"/>
                 </a:solidFill>
               </a:rPr>
               <a:t>Memanfaatkan Agentic AI untuk</a:t>
@@ -1649,16 +1651,17 @@
           </a:p>
           <a:p xmlns:a="http://schemas.openxmlformats.org/drawingml/2006/main">
             <a:pPr algn="l">
+              <a:buNone/>
               <a:defRPr sz="3900" b="1">
                 <a:solidFill>
-                  <a:srgbClr val="0B1628"/>
+                  <a:srgbClr val="4A0B10"/>
                 </a:solidFill>
               </a:defRPr>
             </a:pPr>
             <a:r>
               <a:rPr sz="3900" b="1">
                 <a:solidFill>
-                  <a:srgbClr val="0B1628"/>
+                  <a:srgbClr val="4A0B10"/>
                 </a:solidFill>
               </a:rPr>
               <a:t>Meningkatkan Produktiviti Harian</a:t>
@@ -1689,7 +1692,7 @@
             <a:avLst/>
           </a:prstGeom>
           <a:solidFill xmlns:a="http://schemas.openxmlformats.org/drawingml/2006/main">
-            <a:srgbClr val="00A6A6"/>
+            <a:srgbClr val="AA151B"/>
           </a:solidFill>
           <a:ln xmlns:a="http://schemas.openxmlformats.org/drawingml/2006/main" w="0">
             <a:noFill/>
@@ -1730,16 +1733,17 @@
           <a:lstStyle xmlns:a="http://schemas.openxmlformats.org/drawingml/2006/main"/>
           <a:p xmlns:a="http://schemas.openxmlformats.org/drawingml/2006/main">
             <a:pPr algn="l">
+              <a:buNone/>
               <a:defRPr sz="2025" b="0">
                 <a:solidFill>
-                  <a:srgbClr val="536175"/>
+                  <a:srgbClr val="6F5550"/>
                 </a:solidFill>
               </a:defRPr>
             </a:pPr>
             <a:r>
               <a:rPr sz="2025" b="0">
                 <a:solidFill>
-                  <a:srgbClr val="536175"/>
+                  <a:srgbClr val="6F5550"/>
                 </a:solidFill>
               </a:rPr>
               <a:t>AI sudah boleh menghasilkan jawapan.</a:t>
@@ -1747,16 +1751,17 @@
           </a:p>
           <a:p xmlns:a="http://schemas.openxmlformats.org/drawingml/2006/main">
             <a:pPr algn="l">
+              <a:buNone/>
               <a:defRPr sz="2025" b="0">
                 <a:solidFill>
-                  <a:srgbClr val="536175"/>
+                  <a:srgbClr val="6F5550"/>
                 </a:solidFill>
               </a:defRPr>
             </a:pPr>
             <a:r>
               <a:rPr sz="2025" b="0">
                 <a:solidFill>
-                  <a:srgbClr val="536175"/>
+                  <a:srgbClr val="6F5550"/>
                 </a:solidFill>
               </a:rPr>
               <a:t>Tetapi siapa yang menyiapkan kerja selepas itu?</a:t>
@@ -1797,16 +1802,17 @@
           <a:lstStyle xmlns:a="http://schemas.openxmlformats.org/drawingml/2006/main"/>
           <a:p xmlns:a="http://schemas.openxmlformats.org/drawingml/2006/main">
             <a:pPr algn="l">
+              <a:buNone/>
               <a:defRPr sz="1200" b="0">
                 <a:solidFill>
-                  <a:srgbClr val="536175"/>
+                  <a:srgbClr val="6F5550"/>
                 </a:solidFill>
               </a:defRPr>
             </a:pPr>
             <a:r>
               <a:rPr sz="1200" b="0">
                 <a:solidFill>
-                  <a:srgbClr val="536175"/>
+                  <a:srgbClr val="6F5550"/>
                 </a:solidFill>
               </a:rPr>
               <a:t>Prof. Madya Dr. Mohd Murtadha Mohamad · 21 Julai 2026</a:t>
@@ -1830,7 +1836,7 @@
     <p:bg>
       <p:bgPr>
         <a:solidFill xmlns:a="http://schemas.openxmlformats.org/drawingml/2006/main">
-          <a:srgbClr val="FFFFFF"/>
+          <a:srgbClr val="FFF8E7"/>
         </a:solidFill>
       </p:bgPr>
     </p:bg>
@@ -1876,16 +1882,17 @@
           <a:lstStyle xmlns:a="http://schemas.openxmlformats.org/drawingml/2006/main"/>
           <a:p xmlns:a="http://schemas.openxmlformats.org/drawingml/2006/main">
             <a:pPr algn="l">
+              <a:buNone/>
               <a:defRPr sz="1050" b="1">
                 <a:solidFill>
-                  <a:srgbClr val="536175"/>
+                  <a:srgbClr val="6F5550"/>
                 </a:solidFill>
               </a:defRPr>
             </a:pPr>
             <a:r>
               <a:rPr sz="1050" b="1">
                 <a:solidFill>
-                  <a:srgbClr val="536175"/>
+                  <a:srgbClr val="6F5550"/>
                 </a:solidFill>
               </a:rPr>
               <a:t>IDEA UTAMA</a:t>
@@ -1926,16 +1933,17 @@
           <a:lstStyle xmlns:a="http://schemas.openxmlformats.org/drawingml/2006/main"/>
           <a:p xmlns:a="http://schemas.openxmlformats.org/drawingml/2006/main">
             <a:pPr algn="r">
+              <a:buNone/>
               <a:defRPr sz="1050" b="1">
                 <a:solidFill>
-                  <a:srgbClr val="536175"/>
+                  <a:srgbClr val="6F5550"/>
                 </a:solidFill>
               </a:defRPr>
             </a:pPr>
             <a:r>
               <a:rPr sz="1050" b="1">
                 <a:solidFill>
-                  <a:srgbClr val="536175"/>
+                  <a:srgbClr val="6F5550"/>
                 </a:solidFill>
               </a:rPr>
               <a:t>02</a:t>
@@ -1966,7 +1974,7 @@
             <a:avLst/>
           </a:prstGeom>
           <a:solidFill xmlns:a="http://schemas.openxmlformats.org/drawingml/2006/main">
-            <a:srgbClr val="C8D0DA"/>
+            <a:srgbClr val="D8BD75"/>
           </a:solidFill>
           <a:ln xmlns:a="http://schemas.openxmlformats.org/drawingml/2006/main" w="0">
             <a:noFill/>
@@ -2007,16 +2015,17 @@
           <a:lstStyle xmlns:a="http://schemas.openxmlformats.org/drawingml/2006/main"/>
           <a:p xmlns:a="http://schemas.openxmlformats.org/drawingml/2006/main">
             <a:pPr algn="l">
+              <a:buNone/>
               <a:defRPr sz="3150" b="1">
                 <a:solidFill>
-                  <a:srgbClr val="0B1628"/>
+                  <a:srgbClr val="4A0B10"/>
                 </a:solidFill>
               </a:defRPr>
             </a:pPr>
             <a:r>
               <a:rPr sz="3150" b="1">
                 <a:solidFill>
-                  <a:srgbClr val="0B1628"/>
+                  <a:srgbClr val="4A0B10"/>
                 </a:solidFill>
               </a:rPr>
               <a:t>Generative AI menghasilkan sesuatu.</a:t>
@@ -2024,16 +2033,17 @@
           </a:p>
           <a:p xmlns:a="http://schemas.openxmlformats.org/drawingml/2006/main">
             <a:pPr algn="l">
+              <a:buNone/>
               <a:defRPr sz="3150" b="1">
                 <a:solidFill>
-                  <a:srgbClr val="0B1628"/>
+                  <a:srgbClr val="4A0B10"/>
                 </a:solidFill>
               </a:defRPr>
             </a:pPr>
             <a:r>
               <a:rPr sz="3150" b="1">
                 <a:solidFill>
-                  <a:srgbClr val="0B1628"/>
+                  <a:srgbClr val="4A0B10"/>
                 </a:solidFill>
               </a:rPr>
               <a:t>Agentic AI menyelesaikan sesuatu.</a:t>
@@ -2064,7 +2074,7 @@
             <a:avLst/>
           </a:prstGeom>
           <a:solidFill xmlns:a="http://schemas.openxmlformats.org/drawingml/2006/main">
-            <a:srgbClr val="EEF2F5"/>
+            <a:srgbClr val="F4E4B4"/>
           </a:solidFill>
           <a:ln xmlns:a="http://schemas.openxmlformats.org/drawingml/2006/main" w="0">
             <a:noFill/>
@@ -2105,16 +2115,17 @@
           <a:lstStyle xmlns:a="http://schemas.openxmlformats.org/drawingml/2006/main"/>
           <a:p xmlns:a="http://schemas.openxmlformats.org/drawingml/2006/main">
             <a:pPr algn="l">
+              <a:buNone/>
               <a:defRPr sz="1200" b="1">
                 <a:solidFill>
-                  <a:srgbClr val="536175"/>
+                  <a:srgbClr val="6F5550"/>
                 </a:solidFill>
               </a:defRPr>
             </a:pPr>
             <a:r>
               <a:rPr sz="1200" b="1">
                 <a:solidFill>
-                  <a:srgbClr val="536175"/>
+                  <a:srgbClr val="6F5550"/>
                 </a:solidFill>
               </a:rPr>
               <a:t>GENERATIVE AI</a:t>
@@ -2155,16 +2166,17 @@
           <a:lstStyle xmlns:a="http://schemas.openxmlformats.org/drawingml/2006/main"/>
           <a:p xmlns:a="http://schemas.openxmlformats.org/drawingml/2006/main">
             <a:pPr algn="l">
+              <a:buNone/>
               <a:defRPr sz="1275" b="1">
                 <a:solidFill>
-                  <a:srgbClr val="0B1628"/>
+                  <a:srgbClr val="4A0B10"/>
                 </a:solidFill>
               </a:defRPr>
             </a:pPr>
             <a:r>
               <a:rPr sz="1275" b="1">
                 <a:solidFill>
-                  <a:srgbClr val="0B1628"/>
+                  <a:srgbClr val="4A0B10"/>
                 </a:solidFill>
               </a:rPr>
               <a:t>PROMPT</a:t>
@@ -2205,16 +2217,17 @@
           <a:lstStyle xmlns:a="http://schemas.openxmlformats.org/drawingml/2006/main"/>
           <a:p xmlns:a="http://schemas.openxmlformats.org/drawingml/2006/main">
             <a:pPr algn="ctr">
+              <a:buNone/>
               <a:defRPr sz="2100" b="1">
                 <a:solidFill>
-                  <a:srgbClr val="00A6A6"/>
+                  <a:srgbClr val="AA151B"/>
                 </a:solidFill>
               </a:defRPr>
             </a:pPr>
             <a:r>
               <a:rPr sz="2100" b="1">
                 <a:solidFill>
-                  <a:srgbClr val="00A6A6"/>
+                  <a:srgbClr val="AA151B"/>
                 </a:solidFill>
               </a:rPr>
               <a:t>→</a:t>
@@ -2255,16 +2268,17 @@
           <a:lstStyle xmlns:a="http://schemas.openxmlformats.org/drawingml/2006/main"/>
           <a:p xmlns:a="http://schemas.openxmlformats.org/drawingml/2006/main">
             <a:pPr algn="l">
+              <a:buNone/>
               <a:defRPr sz="1275" b="1">
                 <a:solidFill>
-                  <a:srgbClr val="0B1628"/>
+                  <a:srgbClr val="4A0B10"/>
                 </a:solidFill>
               </a:defRPr>
             </a:pPr>
             <a:r>
               <a:rPr sz="1275" b="1">
                 <a:solidFill>
-                  <a:srgbClr val="0B1628"/>
+                  <a:srgbClr val="4A0B10"/>
                 </a:solidFill>
               </a:rPr>
               <a:t>JAWAPAN</a:t>
@@ -2305,16 +2319,17 @@
           <a:lstStyle xmlns:a="http://schemas.openxmlformats.org/drawingml/2006/main"/>
           <a:p xmlns:a="http://schemas.openxmlformats.org/drawingml/2006/main">
             <a:pPr algn="l">
+              <a:buNone/>
               <a:defRPr sz="1650" b="0">
                 <a:solidFill>
-                  <a:srgbClr val="536175"/>
+                  <a:srgbClr val="6F5550"/>
                 </a:solidFill>
               </a:defRPr>
             </a:pPr>
             <a:r>
               <a:rPr sz="1650" b="0">
                 <a:solidFill>
-                  <a:srgbClr val="536175"/>
+                  <a:srgbClr val="6F5550"/>
                 </a:solidFill>
               </a:rPr>
               <a:t>Menjana teks, imej, idea atau ringkasan—kemudian menunggu arahan seterusnya.</a:t>
@@ -2345,7 +2360,7 @@
             <a:avLst/>
           </a:prstGeom>
           <a:solidFill xmlns:a="http://schemas.openxmlformats.org/drawingml/2006/main">
-            <a:srgbClr val="0B1628"/>
+            <a:srgbClr val="4A0B10"/>
           </a:solidFill>
           <a:ln xmlns:a="http://schemas.openxmlformats.org/drawingml/2006/main" w="0">
             <a:noFill/>
@@ -2386,16 +2401,17 @@
           <a:lstStyle xmlns:a="http://schemas.openxmlformats.org/drawingml/2006/main"/>
           <a:p xmlns:a="http://schemas.openxmlformats.org/drawingml/2006/main">
             <a:pPr algn="l">
+              <a:buNone/>
               <a:defRPr sz="1200" b="1">
                 <a:solidFill>
-                  <a:srgbClr val="C8F135"/>
+                  <a:srgbClr val="F1BF00"/>
                 </a:solidFill>
               </a:defRPr>
             </a:pPr>
             <a:r>
               <a:rPr sz="1200" b="1">
                 <a:solidFill>
-                  <a:srgbClr val="C8F135"/>
+                  <a:srgbClr val="F1BF00"/>
                 </a:solidFill>
               </a:rPr>
               <a:t>AGENTIC AI</a:t>
@@ -2436,16 +2452,17 @@
           <a:lstStyle xmlns:a="http://schemas.openxmlformats.org/drawingml/2006/main"/>
           <a:p xmlns:a="http://schemas.openxmlformats.org/drawingml/2006/main">
             <a:pPr algn="l">
+              <a:buNone/>
               <a:defRPr sz="1275" b="1">
                 <a:solidFill>
-                  <a:srgbClr val="FFFFFF"/>
+                  <a:srgbClr val="FFF8E7"/>
                 </a:solidFill>
               </a:defRPr>
             </a:pPr>
             <a:r>
               <a:rPr sz="1275" b="1">
                 <a:solidFill>
-                  <a:srgbClr val="FFFFFF"/>
+                  <a:srgbClr val="FFF8E7"/>
                 </a:solidFill>
               </a:rPr>
               <a:t>MATLAMAT</a:t>
@@ -2486,16 +2503,17 @@
           <a:lstStyle xmlns:a="http://schemas.openxmlformats.org/drawingml/2006/main"/>
           <a:p xmlns:a="http://schemas.openxmlformats.org/drawingml/2006/main">
             <a:pPr algn="ctr">
+              <a:buNone/>
               <a:defRPr sz="2100" b="1">
                 <a:solidFill>
-                  <a:srgbClr val="C8F135"/>
+                  <a:srgbClr val="F1BF00"/>
                 </a:solidFill>
               </a:defRPr>
             </a:pPr>
             <a:r>
               <a:rPr sz="2100" b="1">
                 <a:solidFill>
-                  <a:srgbClr val="C8F135"/>
+                  <a:srgbClr val="F1BF00"/>
                 </a:solidFill>
               </a:rPr>
               <a:t>→</a:t>
@@ -2536,16 +2554,17 @@
           <a:lstStyle xmlns:a="http://schemas.openxmlformats.org/drawingml/2006/main"/>
           <a:p xmlns:a="http://schemas.openxmlformats.org/drawingml/2006/main">
             <a:pPr algn="l">
+              <a:buNone/>
               <a:defRPr sz="1275" b="1">
                 <a:solidFill>
-                  <a:srgbClr val="FFFFFF"/>
+                  <a:srgbClr val="FFF8E7"/>
                 </a:solidFill>
               </a:defRPr>
             </a:pPr>
             <a:r>
               <a:rPr sz="1275" b="1">
                 <a:solidFill>
-                  <a:srgbClr val="FFFFFF"/>
+                  <a:srgbClr val="FFF8E7"/>
                 </a:solidFill>
               </a:rPr>
               <a:t>HASIL KERJA</a:t>
@@ -2586,16 +2605,17 @@
           <a:lstStyle xmlns:a="http://schemas.openxmlformats.org/drawingml/2006/main"/>
           <a:p xmlns:a="http://schemas.openxmlformats.org/drawingml/2006/main">
             <a:pPr algn="l">
+              <a:buNone/>
               <a:defRPr sz="1650" b="0">
                 <a:solidFill>
-                  <a:srgbClr val="DCE4EE"/>
+                  <a:srgbClr val="F8E9D0"/>
                 </a:solidFill>
               </a:defRPr>
             </a:pPr>
             <a:r>
               <a:rPr sz="1650" b="0">
                 <a:solidFill>
-                  <a:srgbClr val="DCE4EE"/>
+                  <a:srgbClr val="F8E9D0"/>
                 </a:solidFill>
               </a:rPr>
               <a:t>Merancang beberapa langkah, menggunakan sumber dan alat, lalu menyemak hasil.</a:t>
@@ -2619,7 +2639,7 @@
     <p:bg>
       <p:bgPr>
         <a:solidFill xmlns:a="http://schemas.openxmlformats.org/drawingml/2006/main">
-          <a:srgbClr val="FFFFFF"/>
+          <a:srgbClr val="FFF8E7"/>
         </a:solidFill>
       </p:bgPr>
     </p:bg>
@@ -2665,16 +2685,17 @@
           <a:lstStyle xmlns:a="http://schemas.openxmlformats.org/drawingml/2006/main"/>
           <a:p xmlns:a="http://schemas.openxmlformats.org/drawingml/2006/main">
             <a:pPr algn="l">
+              <a:buNone/>
               <a:defRPr sz="1050" b="1">
                 <a:solidFill>
-                  <a:srgbClr val="536175"/>
+                  <a:srgbClr val="6F5550"/>
                 </a:solidFill>
               </a:defRPr>
             </a:pPr>
             <a:r>
               <a:rPr sz="1050" b="1">
                 <a:solidFill>
-                  <a:srgbClr val="536175"/>
+                  <a:srgbClr val="6F5550"/>
                 </a:solidFill>
               </a:rPr>
               <a:t>CARA AGENT BEKERJA</a:t>
@@ -2715,16 +2736,17 @@
           <a:lstStyle xmlns:a="http://schemas.openxmlformats.org/drawingml/2006/main"/>
           <a:p xmlns:a="http://schemas.openxmlformats.org/drawingml/2006/main">
             <a:pPr algn="r">
+              <a:buNone/>
               <a:defRPr sz="1050" b="1">
                 <a:solidFill>
-                  <a:srgbClr val="536175"/>
+                  <a:srgbClr val="6F5550"/>
                 </a:solidFill>
               </a:defRPr>
             </a:pPr>
             <a:r>
               <a:rPr sz="1050" b="1">
                 <a:solidFill>
-                  <a:srgbClr val="536175"/>
+                  <a:srgbClr val="6F5550"/>
                 </a:solidFill>
               </a:rPr>
               <a:t>03</a:t>
@@ -2755,7 +2777,7 @@
             <a:avLst/>
           </a:prstGeom>
           <a:solidFill xmlns:a="http://schemas.openxmlformats.org/drawingml/2006/main">
-            <a:srgbClr val="C8D0DA"/>
+            <a:srgbClr val="D8BD75"/>
           </a:solidFill>
           <a:ln xmlns:a="http://schemas.openxmlformats.org/drawingml/2006/main" w="0">
             <a:noFill/>
@@ -2796,16 +2818,17 @@
           <a:lstStyle xmlns:a="http://schemas.openxmlformats.org/drawingml/2006/main"/>
           <a:p xmlns:a="http://schemas.openxmlformats.org/drawingml/2006/main">
             <a:pPr algn="l">
+              <a:buNone/>
               <a:defRPr sz="3150" b="1">
                 <a:solidFill>
-                  <a:srgbClr val="0B1628"/>
+                  <a:srgbClr val="4A0B10"/>
                 </a:solidFill>
               </a:defRPr>
             </a:pPr>
             <a:r>
               <a:rPr sz="3150" b="1">
                 <a:solidFill>
-                  <a:srgbClr val="0B1628"/>
+                  <a:srgbClr val="4A0B10"/>
                 </a:solidFill>
               </a:rPr>
               <a:t>Agent mengubah satu matlamat menjadi beberapa tindakan.</a:t>
@@ -2836,7 +2859,7 @@
             <a:avLst/>
           </a:prstGeom>
           <a:solidFill xmlns:a="http://schemas.openxmlformats.org/drawingml/2006/main">
-            <a:srgbClr val="EEF2F5"/>
+            <a:srgbClr val="F4E4B4"/>
           </a:solidFill>
           <a:ln xmlns:a="http://schemas.openxmlformats.org/drawingml/2006/main" w="0">
             <a:noFill/>
@@ -2877,16 +2900,17 @@
           <a:lstStyle xmlns:a="http://schemas.openxmlformats.org/drawingml/2006/main"/>
           <a:p xmlns:a="http://schemas.openxmlformats.org/drawingml/2006/main">
             <a:pPr algn="l">
+              <a:buNone/>
               <a:defRPr sz="1650" b="1">
                 <a:solidFill>
-                  <a:srgbClr val="0B1628"/>
+                  <a:srgbClr val="4A0B10"/>
                 </a:solidFill>
               </a:defRPr>
             </a:pPr>
             <a:r>
               <a:rPr sz="1650" b="1">
                 <a:solidFill>
-                  <a:srgbClr val="0B1628"/>
+                  <a:srgbClr val="4A0B10"/>
                 </a:solidFill>
               </a:rPr>
               <a:t>1  Fahami</a:t>
@@ -2927,16 +2951,17 @@
           <a:lstStyle xmlns:a="http://schemas.openxmlformats.org/drawingml/2006/main"/>
           <a:p xmlns:a="http://schemas.openxmlformats.org/drawingml/2006/main">
             <a:pPr algn="l">
+              <a:buNone/>
               <a:defRPr sz="1425" b="0">
                 <a:solidFill>
-                  <a:srgbClr val="536175"/>
+                  <a:srgbClr val="6F5550"/>
                 </a:solidFill>
               </a:defRPr>
             </a:pPr>
             <a:r>
               <a:rPr sz="1425" b="0">
                 <a:solidFill>
-                  <a:srgbClr val="536175"/>
+                  <a:srgbClr val="6F5550"/>
                 </a:solidFill>
               </a:rPr>
               <a:t>Kenal pasti hasil dan batasan.</a:t>
@@ -2977,16 +3002,17 @@
           <a:lstStyle xmlns:a="http://schemas.openxmlformats.org/drawingml/2006/main"/>
           <a:p xmlns:a="http://schemas.openxmlformats.org/drawingml/2006/main">
             <a:pPr algn="ctr">
+              <a:buNone/>
               <a:defRPr sz="1950" b="1">
                 <a:solidFill>
-                  <a:srgbClr val="00A6A6"/>
+                  <a:srgbClr val="AA151B"/>
                 </a:solidFill>
               </a:defRPr>
             </a:pPr>
             <a:r>
               <a:rPr sz="1950" b="1">
                 <a:solidFill>
-                  <a:srgbClr val="00A6A6"/>
+                  <a:srgbClr val="AA151B"/>
                 </a:solidFill>
               </a:rPr>
               <a:t>→</a:t>
@@ -3017,7 +3043,7 @@
             <a:avLst/>
           </a:prstGeom>
           <a:solidFill xmlns:a="http://schemas.openxmlformats.org/drawingml/2006/main">
-            <a:srgbClr val="EEF2F5"/>
+            <a:srgbClr val="F4E4B4"/>
           </a:solidFill>
           <a:ln xmlns:a="http://schemas.openxmlformats.org/drawingml/2006/main" w="0">
             <a:noFill/>
@@ -3058,16 +3084,17 @@
           <a:lstStyle xmlns:a="http://schemas.openxmlformats.org/drawingml/2006/main"/>
           <a:p xmlns:a="http://schemas.openxmlformats.org/drawingml/2006/main">
             <a:pPr algn="l">
+              <a:buNone/>
               <a:defRPr sz="1650" b="1">
                 <a:solidFill>
-                  <a:srgbClr val="0B1628"/>
+                  <a:srgbClr val="4A0B10"/>
                 </a:solidFill>
               </a:defRPr>
             </a:pPr>
             <a:r>
               <a:rPr sz="1650" b="1">
                 <a:solidFill>
-                  <a:srgbClr val="0B1628"/>
+                  <a:srgbClr val="4A0B10"/>
                 </a:solidFill>
               </a:rPr>
               <a:t>2  Rancang</a:t>
@@ -3108,16 +3135,17 @@
           <a:lstStyle xmlns:a="http://schemas.openxmlformats.org/drawingml/2006/main"/>
           <a:p xmlns:a="http://schemas.openxmlformats.org/drawingml/2006/main">
             <a:pPr algn="l">
+              <a:buNone/>
               <a:defRPr sz="1425" b="0">
                 <a:solidFill>
-                  <a:srgbClr val="536175"/>
+                  <a:srgbClr val="6F5550"/>
                 </a:solidFill>
               </a:defRPr>
             </a:pPr>
             <a:r>
               <a:rPr sz="1425" b="0">
                 <a:solidFill>
-                  <a:srgbClr val="536175"/>
+                  <a:srgbClr val="6F5550"/>
                 </a:solidFill>
               </a:rPr>
               <a:t>Susun langkah yang diperlukan.</a:t>
@@ -3158,16 +3186,17 @@
           <a:lstStyle xmlns:a="http://schemas.openxmlformats.org/drawingml/2006/main"/>
           <a:p xmlns:a="http://schemas.openxmlformats.org/drawingml/2006/main">
             <a:pPr algn="ctr">
+              <a:buNone/>
               <a:defRPr sz="1950" b="1">
                 <a:solidFill>
-                  <a:srgbClr val="00A6A6"/>
+                  <a:srgbClr val="AA151B"/>
                 </a:solidFill>
               </a:defRPr>
             </a:pPr>
             <a:r>
               <a:rPr sz="1950" b="1">
                 <a:solidFill>
-                  <a:srgbClr val="00A6A6"/>
+                  <a:srgbClr val="AA151B"/>
                 </a:solidFill>
               </a:rPr>
               <a:t>→</a:t>
@@ -3198,7 +3227,7 @@
             <a:avLst/>
           </a:prstGeom>
           <a:solidFill xmlns:a="http://schemas.openxmlformats.org/drawingml/2006/main">
-            <a:srgbClr val="EEF2F5"/>
+            <a:srgbClr val="F4E4B4"/>
           </a:solidFill>
           <a:ln xmlns:a="http://schemas.openxmlformats.org/drawingml/2006/main" w="0">
             <a:noFill/>
@@ -3239,16 +3268,17 @@
           <a:lstStyle xmlns:a="http://schemas.openxmlformats.org/drawingml/2006/main"/>
           <a:p xmlns:a="http://schemas.openxmlformats.org/drawingml/2006/main">
             <a:pPr algn="l">
+              <a:buNone/>
               <a:defRPr sz="1650" b="1">
                 <a:solidFill>
-                  <a:srgbClr val="0B1628"/>
+                  <a:srgbClr val="4A0B10"/>
                 </a:solidFill>
               </a:defRPr>
             </a:pPr>
             <a:r>
               <a:rPr sz="1650" b="1">
                 <a:solidFill>
-                  <a:srgbClr val="0B1628"/>
+                  <a:srgbClr val="4A0B10"/>
                 </a:solidFill>
               </a:rPr>
               <a:t>3  Gunakan alat</a:t>
@@ -3289,16 +3319,17 @@
           <a:lstStyle xmlns:a="http://schemas.openxmlformats.org/drawingml/2006/main"/>
           <a:p xmlns:a="http://schemas.openxmlformats.org/drawingml/2006/main">
             <a:pPr algn="l">
+              <a:buNone/>
               <a:defRPr sz="1425" b="0">
                 <a:solidFill>
-                  <a:srgbClr val="536175"/>
+                  <a:srgbClr val="6F5550"/>
                 </a:solidFill>
               </a:defRPr>
             </a:pPr>
             <a:r>
               <a:rPr sz="1425" b="0">
                 <a:solidFill>
-                  <a:srgbClr val="536175"/>
+                  <a:srgbClr val="6F5550"/>
                 </a:solidFill>
               </a:rPr>
               <a:t>Baca fail, data atau aplikasi.</a:t>
@@ -3339,16 +3370,17 @@
           <a:lstStyle xmlns:a="http://schemas.openxmlformats.org/drawingml/2006/main"/>
           <a:p xmlns:a="http://schemas.openxmlformats.org/drawingml/2006/main">
             <a:pPr algn="ctr">
+              <a:buNone/>
               <a:defRPr sz="1950" b="1">
                 <a:solidFill>
-                  <a:srgbClr val="00A6A6"/>
+                  <a:srgbClr val="AA151B"/>
                 </a:solidFill>
               </a:defRPr>
             </a:pPr>
             <a:r>
               <a:rPr sz="1950" b="1">
                 <a:solidFill>
-                  <a:srgbClr val="00A6A6"/>
+                  <a:srgbClr val="AA151B"/>
                 </a:solidFill>
               </a:rPr>
               <a:t>→</a:t>
@@ -3379,7 +3411,7 @@
             <a:avLst/>
           </a:prstGeom>
           <a:solidFill xmlns:a="http://schemas.openxmlformats.org/drawingml/2006/main">
-            <a:srgbClr val="EEF2F5"/>
+            <a:srgbClr val="F4E4B4"/>
           </a:solidFill>
           <a:ln xmlns:a="http://schemas.openxmlformats.org/drawingml/2006/main" w="0">
             <a:noFill/>
@@ -3420,16 +3452,17 @@
           <a:lstStyle xmlns:a="http://schemas.openxmlformats.org/drawingml/2006/main"/>
           <a:p xmlns:a="http://schemas.openxmlformats.org/drawingml/2006/main">
             <a:pPr algn="l">
+              <a:buNone/>
               <a:defRPr sz="1650" b="1">
                 <a:solidFill>
-                  <a:srgbClr val="0B1628"/>
+                  <a:srgbClr val="4A0B10"/>
                 </a:solidFill>
               </a:defRPr>
             </a:pPr>
             <a:r>
               <a:rPr sz="1650" b="1">
                 <a:solidFill>
-                  <a:srgbClr val="0B1628"/>
+                  <a:srgbClr val="4A0B10"/>
                 </a:solidFill>
               </a:rPr>
               <a:t>4  Hasilkan</a:t>
@@ -3470,16 +3503,17 @@
           <a:lstStyle xmlns:a="http://schemas.openxmlformats.org/drawingml/2006/main"/>
           <a:p xmlns:a="http://schemas.openxmlformats.org/drawingml/2006/main">
             <a:pPr algn="l">
+              <a:buNone/>
               <a:defRPr sz="1425" b="0">
                 <a:solidFill>
-                  <a:srgbClr val="536175"/>
+                  <a:srgbClr val="6F5550"/>
                 </a:solidFill>
               </a:defRPr>
             </a:pPr>
             <a:r>
               <a:rPr sz="1425" b="0">
                 <a:solidFill>
-                  <a:srgbClr val="536175"/>
+                  <a:srgbClr val="6F5550"/>
                 </a:solidFill>
               </a:rPr>
               <a:t>Cipta dokumen atau kemas kini kerja.</a:t>
@@ -3520,16 +3554,17 @@
           <a:lstStyle xmlns:a="http://schemas.openxmlformats.org/drawingml/2006/main"/>
           <a:p xmlns:a="http://schemas.openxmlformats.org/drawingml/2006/main">
             <a:pPr algn="ctr">
+              <a:buNone/>
               <a:defRPr sz="1950" b="1">
                 <a:solidFill>
-                  <a:srgbClr val="00A6A6"/>
+                  <a:srgbClr val="AA151B"/>
                 </a:solidFill>
               </a:defRPr>
             </a:pPr>
             <a:r>
               <a:rPr sz="1950" b="1">
                 <a:solidFill>
-                  <a:srgbClr val="00A6A6"/>
+                  <a:srgbClr val="AA151B"/>
                 </a:solidFill>
               </a:rPr>
               <a:t>→</a:t>
@@ -3560,7 +3595,7 @@
             <a:avLst/>
           </a:prstGeom>
           <a:solidFill xmlns:a="http://schemas.openxmlformats.org/drawingml/2006/main">
-            <a:srgbClr val="0B1628"/>
+            <a:srgbClr val="4A0B10"/>
           </a:solidFill>
           <a:ln xmlns:a="http://schemas.openxmlformats.org/drawingml/2006/main" w="0">
             <a:noFill/>
@@ -3601,16 +3636,17 @@
           <a:lstStyle xmlns:a="http://schemas.openxmlformats.org/drawingml/2006/main"/>
           <a:p xmlns:a="http://schemas.openxmlformats.org/drawingml/2006/main">
             <a:pPr algn="l">
+              <a:buNone/>
               <a:defRPr sz="1650" b="1">
                 <a:solidFill>
-                  <a:srgbClr val="C8F135"/>
+                  <a:srgbClr val="F1BF00"/>
                 </a:solidFill>
               </a:defRPr>
             </a:pPr>
             <a:r>
               <a:rPr sz="1650" b="1">
                 <a:solidFill>
-                  <a:srgbClr val="C8F135"/>
+                  <a:srgbClr val="F1BF00"/>
                 </a:solidFill>
               </a:rPr>
               <a:t>5  Semak</a:t>
@@ -3651,16 +3687,17 @@
           <a:lstStyle xmlns:a="http://schemas.openxmlformats.org/drawingml/2006/main"/>
           <a:p xmlns:a="http://schemas.openxmlformats.org/drawingml/2006/main">
             <a:pPr algn="l">
+              <a:buNone/>
               <a:defRPr sz="1425" b="0">
                 <a:solidFill>
-                  <a:srgbClr val="FFFFFF"/>
+                  <a:srgbClr val="FFF8E7"/>
                 </a:solidFill>
               </a:defRPr>
             </a:pPr>
             <a:r>
               <a:rPr sz="1425" b="0">
                 <a:solidFill>
-                  <a:srgbClr val="FFFFFF"/>
+                  <a:srgbClr val="FFF8E7"/>
                 </a:solidFill>
               </a:rPr>
               <a:t>Uji hasil dan baiki jurang.</a:t>
@@ -3691,7 +3728,7 @@
             <a:avLst/>
           </a:prstGeom>
           <a:solidFill xmlns:a="http://schemas.openxmlformats.org/drawingml/2006/main">
-            <a:srgbClr val="E5FBF8"/>
+            <a:srgbClr val="FFE59A"/>
           </a:solidFill>
           <a:ln xmlns:a="http://schemas.openxmlformats.org/drawingml/2006/main" w="0">
             <a:noFill/>
@@ -3732,16 +3769,17 @@
           <a:lstStyle xmlns:a="http://schemas.openxmlformats.org/drawingml/2006/main"/>
           <a:p xmlns:a="http://schemas.openxmlformats.org/drawingml/2006/main">
             <a:pPr algn="ctr">
+              <a:buNone/>
               <a:defRPr sz="1800" b="1">
                 <a:solidFill>
-                  <a:srgbClr val="0B1628"/>
+                  <a:srgbClr val="4A0B10"/>
                 </a:solidFill>
               </a:defRPr>
             </a:pPr>
             <a:r>
               <a:rPr sz="1800" b="1">
                 <a:solidFill>
-                  <a:srgbClr val="0B1628"/>
+                  <a:srgbClr val="4A0B10"/>
                 </a:solidFill>
               </a:rPr>
               <a:t>Manusia menetapkan matlamat, memberi akses dan meluluskan keputusan penting.</a:t>
@@ -3765,7 +3803,7 @@
     <p:bg>
       <p:bgPr>
         <a:solidFill xmlns:a="http://schemas.openxmlformats.org/drawingml/2006/main">
-          <a:srgbClr val="FFFFFF"/>
+          <a:srgbClr val="FFF8E7"/>
         </a:solidFill>
       </p:bgPr>
     </p:bg>
@@ -3811,16 +3849,17 @@
           <a:lstStyle xmlns:a="http://schemas.openxmlformats.org/drawingml/2006/main"/>
           <a:p xmlns:a="http://schemas.openxmlformats.org/drawingml/2006/main">
             <a:pPr algn="l">
+              <a:buNone/>
               <a:defRPr sz="1050" b="1">
                 <a:solidFill>
-                  <a:srgbClr val="536175"/>
+                  <a:srgbClr val="6F5550"/>
                 </a:solidFill>
               </a:defRPr>
             </a:pPr>
             <a:r>
               <a:rPr sz="1050" b="1">
                 <a:solidFill>
-                  <a:srgbClr val="536175"/>
+                  <a:srgbClr val="6F5550"/>
                 </a:solidFill>
               </a:rPr>
               <a:t>CONTOH KERJA UTM</a:t>
@@ -3861,16 +3900,17 @@
           <a:lstStyle xmlns:a="http://schemas.openxmlformats.org/drawingml/2006/main"/>
           <a:p xmlns:a="http://schemas.openxmlformats.org/drawingml/2006/main">
             <a:pPr algn="r">
+              <a:buNone/>
               <a:defRPr sz="1050" b="1">
                 <a:solidFill>
-                  <a:srgbClr val="536175"/>
+                  <a:srgbClr val="6F5550"/>
                 </a:solidFill>
               </a:defRPr>
             </a:pPr>
             <a:r>
               <a:rPr sz="1050" b="1">
                 <a:solidFill>
-                  <a:srgbClr val="536175"/>
+                  <a:srgbClr val="6F5550"/>
                 </a:solidFill>
               </a:rPr>
               <a:t>04</a:t>
@@ -3901,7 +3941,7 @@
             <a:avLst/>
           </a:prstGeom>
           <a:solidFill xmlns:a="http://schemas.openxmlformats.org/drawingml/2006/main">
-            <a:srgbClr val="C8D0DA"/>
+            <a:srgbClr val="D8BD75"/>
           </a:solidFill>
           <a:ln xmlns:a="http://schemas.openxmlformats.org/drawingml/2006/main" w="0">
             <a:noFill/>
@@ -3942,16 +3982,17 @@
           <a:lstStyle xmlns:a="http://schemas.openxmlformats.org/drawingml/2006/main"/>
           <a:p xmlns:a="http://schemas.openxmlformats.org/drawingml/2006/main">
             <a:pPr algn="l">
+              <a:buNone/>
               <a:defRPr sz="3150" b="1">
                 <a:solidFill>
-                  <a:srgbClr val="0B1628"/>
+                  <a:srgbClr val="4A0B10"/>
                 </a:solidFill>
               </a:defRPr>
             </a:pPr>
             <a:r>
               <a:rPr sz="3150" b="1">
                 <a:solidFill>
-                  <a:srgbClr val="0B1628"/>
+                  <a:srgbClr val="4A0B10"/>
                 </a:solidFill>
               </a:rPr>
               <a:t>Satu tugasan biasa boleh menjadi aliran kerja agent.</a:t>
@@ -3992,16 +4033,17 @@
           <a:lstStyle xmlns:a="http://schemas.openxmlformats.org/drawingml/2006/main"/>
           <a:p xmlns:a="http://schemas.openxmlformats.org/drawingml/2006/main">
             <a:pPr algn="l">
+              <a:buNone/>
               <a:defRPr sz="1200" b="1">
                 <a:solidFill>
-                  <a:srgbClr val="536175"/>
+                  <a:srgbClr val="6F5550"/>
                 </a:solidFill>
               </a:defRPr>
             </a:pPr>
             <a:r>
               <a:rPr sz="1200" b="1">
                 <a:solidFill>
-                  <a:srgbClr val="536175"/>
+                  <a:srgbClr val="6F5550"/>
                 </a:solidFill>
               </a:rPr>
               <a:t>SELEPAS PROGRAM</a:t>
@@ -4042,16 +4084,17 @@
           <a:lstStyle xmlns:a="http://schemas.openxmlformats.org/drawingml/2006/main"/>
           <a:p xmlns:a="http://schemas.openxmlformats.org/drawingml/2006/main">
             <a:pPr algn="l">
+              <a:buNone/>
               <a:defRPr sz="2400" b="1">
                 <a:solidFill>
-                  <a:srgbClr val="0B1628"/>
+                  <a:srgbClr val="4A0B10"/>
                 </a:solidFill>
               </a:defRPr>
             </a:pPr>
             <a:r>
               <a:rPr sz="2400" b="1">
                 <a:solidFill>
-                  <a:srgbClr val="0B1628"/>
+                  <a:srgbClr val="4A0B10"/>
                 </a:solidFill>
               </a:rPr>
               <a:t>Sediakan pakej susulan</a:t>
@@ -4059,16 +4102,17 @@
           </a:p>
           <a:p xmlns:a="http://schemas.openxmlformats.org/drawingml/2006/main">
             <a:pPr algn="l">
+              <a:buNone/>
               <a:defRPr sz="2400" b="1">
                 <a:solidFill>
-                  <a:srgbClr val="0B1628"/>
+                  <a:srgbClr val="4A0B10"/>
                 </a:solidFill>
               </a:defRPr>
             </a:pPr>
             <a:r>
               <a:rPr sz="2400" b="1">
                 <a:solidFill>
-                  <a:srgbClr val="0B1628"/>
+                  <a:srgbClr val="4A0B10"/>
                 </a:solidFill>
               </a:rPr>
               <a:t>untuk urus setia.</a:t>
@@ -4109,16 +4153,17 @@
           <a:lstStyle xmlns:a="http://schemas.openxmlformats.org/drawingml/2006/main"/>
           <a:p xmlns:a="http://schemas.openxmlformats.org/drawingml/2006/main">
             <a:pPr algn="l">
+              <a:buNone/>
               <a:defRPr sz="1350" b="1">
                 <a:solidFill>
-                  <a:srgbClr val="536175"/>
+                  <a:srgbClr val="6F5550"/>
                 </a:solidFill>
               </a:defRPr>
             </a:pPr>
             <a:r>
               <a:rPr sz="1350" b="1">
                 <a:solidFill>
-                  <a:srgbClr val="536175"/>
+                  <a:srgbClr val="6F5550"/>
                 </a:solidFill>
               </a:rPr>
               <a:t>Sumber</a:t>
@@ -4149,7 +4194,7 @@
             <a:avLst/>
           </a:prstGeom>
           <a:solidFill xmlns:a="http://schemas.openxmlformats.org/drawingml/2006/main">
-            <a:srgbClr val="EEF2F5"/>
+            <a:srgbClr val="F4E4B4"/>
           </a:solidFill>
           <a:ln xmlns:a="http://schemas.openxmlformats.org/drawingml/2006/main" w="0">
             <a:noFill/>
@@ -4190,16 +4235,17 @@
           <a:lstStyle xmlns:a="http://schemas.openxmlformats.org/drawingml/2006/main"/>
           <a:p xmlns:a="http://schemas.openxmlformats.org/drawingml/2006/main">
             <a:pPr algn="l">
+              <a:buNone/>
               <a:defRPr sz="1425" b="1">
                 <a:solidFill>
-                  <a:srgbClr val="0B1628"/>
+                  <a:srgbClr val="4A0B10"/>
                 </a:solidFill>
               </a:defRPr>
             </a:pPr>
             <a:r>
               <a:rPr sz="1425" b="1">
                 <a:solidFill>
-                  <a:srgbClr val="0B1628"/>
+                  <a:srgbClr val="4A0B10"/>
                 </a:solidFill>
               </a:rPr>
               <a:t>Nota mesyuarat</a:t>
@@ -4230,7 +4276,7 @@
             <a:avLst/>
           </a:prstGeom>
           <a:solidFill xmlns:a="http://schemas.openxmlformats.org/drawingml/2006/main">
-            <a:srgbClr val="EEF2F5"/>
+            <a:srgbClr val="F4E4B4"/>
           </a:solidFill>
           <a:ln xmlns:a="http://schemas.openxmlformats.org/drawingml/2006/main" w="0">
             <a:noFill/>
@@ -4271,16 +4317,17 @@
           <a:lstStyle xmlns:a="http://schemas.openxmlformats.org/drawingml/2006/main"/>
           <a:p xmlns:a="http://schemas.openxmlformats.org/drawingml/2006/main">
             <a:pPr algn="l">
+              <a:buNone/>
               <a:defRPr sz="1425" b="1">
                 <a:solidFill>
-                  <a:srgbClr val="0B1628"/>
+                  <a:srgbClr val="4A0B10"/>
                 </a:solidFill>
               </a:defRPr>
             </a:pPr>
             <a:r>
               <a:rPr sz="1425" b="1">
                 <a:solidFill>
-                  <a:srgbClr val="0B1628"/>
+                  <a:srgbClr val="4A0B10"/>
                 </a:solidFill>
               </a:rPr>
               <a:t>Rekod kehadiran</a:t>
@@ -4311,7 +4358,7 @@
             <a:avLst/>
           </a:prstGeom>
           <a:solidFill xmlns:a="http://schemas.openxmlformats.org/drawingml/2006/main">
-            <a:srgbClr val="EEF2F5"/>
+            <a:srgbClr val="F4E4B4"/>
           </a:solidFill>
           <a:ln xmlns:a="http://schemas.openxmlformats.org/drawingml/2006/main" w="0">
             <a:noFill/>
@@ -4352,16 +4399,17 @@
           <a:lstStyle xmlns:a="http://schemas.openxmlformats.org/drawingml/2006/main"/>
           <a:p xmlns:a="http://schemas.openxmlformats.org/drawingml/2006/main">
             <a:pPr algn="l">
+              <a:buNone/>
               <a:defRPr sz="1425" b="1">
                 <a:solidFill>
-                  <a:srgbClr val="0B1628"/>
+                  <a:srgbClr val="4A0B10"/>
                 </a:solidFill>
               </a:defRPr>
             </a:pPr>
             <a:r>
               <a:rPr sz="1425" b="1">
                 <a:solidFill>
-                  <a:srgbClr val="0B1628"/>
+                  <a:srgbClr val="4A0B10"/>
                 </a:solidFill>
               </a:rPr>
               <a:t>Maklum balas</a:t>
@@ -4402,16 +4450,17 @@
           <a:lstStyle xmlns:a="http://schemas.openxmlformats.org/drawingml/2006/main"/>
           <a:p xmlns:a="http://schemas.openxmlformats.org/drawingml/2006/main">
             <a:pPr algn="l">
+              <a:buNone/>
               <a:defRPr sz="1350" b="1">
                 <a:solidFill>
-                  <a:srgbClr val="536175"/>
+                  <a:srgbClr val="6F5550"/>
                 </a:solidFill>
               </a:defRPr>
             </a:pPr>
             <a:r>
               <a:rPr sz="1350" b="1">
                 <a:solidFill>
-                  <a:srgbClr val="536175"/>
+                  <a:srgbClr val="6F5550"/>
                 </a:solidFill>
               </a:rPr>
               <a:t>Hasil</a:t>
@@ -4442,7 +4491,7 @@
             <a:avLst/>
           </a:prstGeom>
           <a:solidFill xmlns:a="http://schemas.openxmlformats.org/drawingml/2006/main">
-            <a:srgbClr val="E5FBF8"/>
+            <a:srgbClr val="FFE59A"/>
           </a:solidFill>
           <a:ln xmlns:a="http://schemas.openxmlformats.org/drawingml/2006/main" w="0">
             <a:noFill/>
@@ -4483,16 +4532,17 @@
           <a:lstStyle xmlns:a="http://schemas.openxmlformats.org/drawingml/2006/main"/>
           <a:p xmlns:a="http://schemas.openxmlformats.org/drawingml/2006/main">
             <a:pPr algn="l">
+              <a:buNone/>
               <a:defRPr sz="1425" b="1">
                 <a:solidFill>
-                  <a:srgbClr val="0B1628"/>
+                  <a:srgbClr val="4A0B10"/>
                 </a:solidFill>
               </a:defRPr>
             </a:pPr>
             <a:r>
               <a:rPr sz="1425" b="1">
                 <a:solidFill>
-                  <a:srgbClr val="0B1628"/>
+                  <a:srgbClr val="4A0B10"/>
                 </a:solidFill>
               </a:rPr>
               <a:t>Ringkasan pengurusan</a:t>
@@ -4523,7 +4573,7 @@
             <a:avLst/>
           </a:prstGeom>
           <a:solidFill xmlns:a="http://schemas.openxmlformats.org/drawingml/2006/main">
-            <a:srgbClr val="E5FBF8"/>
+            <a:srgbClr val="FFE59A"/>
           </a:solidFill>
           <a:ln xmlns:a="http://schemas.openxmlformats.org/drawingml/2006/main" w="0">
             <a:noFill/>
@@ -4564,16 +4614,17 @@
           <a:lstStyle xmlns:a="http://schemas.openxmlformats.org/drawingml/2006/main"/>
           <a:p xmlns:a="http://schemas.openxmlformats.org/drawingml/2006/main">
             <a:pPr algn="l">
+              <a:buNone/>
               <a:defRPr sz="1425" b="1">
                 <a:solidFill>
-                  <a:srgbClr val="0B1628"/>
+                  <a:srgbClr val="4A0B10"/>
                 </a:solidFill>
               </a:defRPr>
             </a:pPr>
             <a:r>
               <a:rPr sz="1425" b="1">
                 <a:solidFill>
-                  <a:srgbClr val="0B1628"/>
+                  <a:srgbClr val="4A0B10"/>
                 </a:solidFill>
               </a:rPr>
               <a:t>Jadual tindakan</a:t>
@@ -4604,7 +4655,7 @@
             <a:avLst/>
           </a:prstGeom>
           <a:solidFill xmlns:a="http://schemas.openxmlformats.org/drawingml/2006/main">
-            <a:srgbClr val="0B1628"/>
+            <a:srgbClr val="4A0B10"/>
           </a:solidFill>
           <a:ln xmlns:a="http://schemas.openxmlformats.org/drawingml/2006/main" w="0">
             <a:noFill/>
@@ -4645,16 +4696,17 @@
           <a:lstStyle xmlns:a="http://schemas.openxmlformats.org/drawingml/2006/main"/>
           <a:p xmlns:a="http://schemas.openxmlformats.org/drawingml/2006/main">
             <a:pPr algn="l">
+              <a:buNone/>
               <a:defRPr sz="1425" b="1">
                 <a:solidFill>
-                  <a:srgbClr val="FFFFFF"/>
+                  <a:srgbClr val="FFF8E7"/>
                 </a:solidFill>
               </a:defRPr>
             </a:pPr>
             <a:r>
               <a:rPr sz="1425" b="1">
                 <a:solidFill>
-                  <a:srgbClr val="FFFFFF"/>
+                  <a:srgbClr val="FFF8E7"/>
                 </a:solidFill>
               </a:rPr>
               <a:t>Draf e-mel susulan</a:t>
@@ -4685,7 +4737,7 @@
             <a:avLst/>
           </a:prstGeom>
           <a:solidFill xmlns:a="http://schemas.openxmlformats.org/drawingml/2006/main">
-            <a:srgbClr val="00A6A6"/>
+            <a:srgbClr val="AA151B"/>
           </a:solidFill>
           <a:ln xmlns:a="http://schemas.openxmlformats.org/drawingml/2006/main" w="0">
             <a:noFill/>
@@ -4716,7 +4768,7 @@
             <a:avLst/>
           </a:prstGeom>
           <a:solidFill xmlns:a="http://schemas.openxmlformats.org/drawingml/2006/main">
-            <a:srgbClr val="00A6A6"/>
+            <a:srgbClr val="AA151B"/>
           </a:solidFill>
           <a:ln xmlns:a="http://schemas.openxmlformats.org/drawingml/2006/main" w="0">
             <a:noFill/>
@@ -4757,16 +4809,17 @@
           <a:lstStyle xmlns:a="http://schemas.openxmlformats.org/drawingml/2006/main"/>
           <a:p xmlns:a="http://schemas.openxmlformats.org/drawingml/2006/main">
             <a:pPr algn="l">
+              <a:buNone/>
               <a:defRPr sz="1800" b="0">
                 <a:solidFill>
-                  <a:srgbClr val="536175"/>
+                  <a:srgbClr val="6F5550"/>
                 </a:solidFill>
               </a:defRPr>
             </a:pPr>
             <a:r>
               <a:rPr sz="1800" b="0">
                 <a:solidFill>
-                  <a:srgbClr val="536175"/>
+                  <a:srgbClr val="6F5550"/>
                 </a:solidFill>
               </a:rPr>
               <a:t>Agent membaca sumber, menyusun kerja dan menandakan perkara yang perlu disahkan.</a:t>
@@ -4790,7 +4843,7 @@
     <p:bg>
       <p:bgPr>
         <a:solidFill xmlns:a="http://schemas.openxmlformats.org/drawingml/2006/main">
-          <a:srgbClr val="FFFFFF"/>
+          <a:srgbClr val="FFF8E7"/>
         </a:solidFill>
       </p:bgPr>
     </p:bg>
@@ -4836,16 +4889,17 @@
           <a:lstStyle xmlns:a="http://schemas.openxmlformats.org/drawingml/2006/main"/>
           <a:p xmlns:a="http://schemas.openxmlformats.org/drawingml/2006/main">
             <a:pPr algn="l">
+              <a:buNone/>
               <a:defRPr sz="1050" b="1">
                 <a:solidFill>
-                  <a:srgbClr val="536175"/>
+                  <a:srgbClr val="6F5550"/>
                 </a:solidFill>
               </a:defRPr>
             </a:pPr>
             <a:r>
               <a:rPr sz="1050" b="1">
                 <a:solidFill>
-                  <a:srgbClr val="536175"/>
+                  <a:srgbClr val="6F5550"/>
                 </a:solidFill>
               </a:rPr>
               <a:t>ANATOMI AGENT</a:t>
@@ -4886,16 +4940,17 @@
           <a:lstStyle xmlns:a="http://schemas.openxmlformats.org/drawingml/2006/main"/>
           <a:p xmlns:a="http://schemas.openxmlformats.org/drawingml/2006/main">
             <a:pPr algn="r">
+              <a:buNone/>
               <a:defRPr sz="1050" b="1">
                 <a:solidFill>
-                  <a:srgbClr val="536175"/>
+                  <a:srgbClr val="6F5550"/>
                 </a:solidFill>
               </a:defRPr>
             </a:pPr>
             <a:r>
               <a:rPr sz="1050" b="1">
                 <a:solidFill>
-                  <a:srgbClr val="536175"/>
+                  <a:srgbClr val="6F5550"/>
                 </a:solidFill>
               </a:rPr>
               <a:t>05</a:t>
@@ -4926,7 +4981,7 @@
             <a:avLst/>
           </a:prstGeom>
           <a:solidFill xmlns:a="http://schemas.openxmlformats.org/drawingml/2006/main">
-            <a:srgbClr val="C8D0DA"/>
+            <a:srgbClr val="D8BD75"/>
           </a:solidFill>
           <a:ln xmlns:a="http://schemas.openxmlformats.org/drawingml/2006/main" w="0">
             <a:noFill/>
@@ -4967,16 +5022,17 @@
           <a:lstStyle xmlns:a="http://schemas.openxmlformats.org/drawingml/2006/main"/>
           <a:p xmlns:a="http://schemas.openxmlformats.org/drawingml/2006/main">
             <a:pPr algn="l">
+              <a:buNone/>
               <a:defRPr sz="3150" b="1">
                 <a:solidFill>
-                  <a:srgbClr val="0B1628"/>
+                  <a:srgbClr val="4A0B10"/>
                 </a:solidFill>
               </a:defRPr>
             </a:pPr>
             <a:r>
               <a:rPr sz="3150" b="1">
                 <a:solidFill>
-                  <a:srgbClr val="0B1628"/>
+                  <a:srgbClr val="4A0B10"/>
                 </a:solidFill>
               </a:rPr>
               <a:t>Agent menjadi berguna apabila mempunyai konteks dan alat.</a:t>
@@ -5007,7 +5063,7 @@
             <a:avLst/>
           </a:prstGeom>
           <a:solidFill xmlns:a="http://schemas.openxmlformats.org/drawingml/2006/main">
-            <a:srgbClr val="EEF2F5"/>
+            <a:srgbClr val="F4E4B4"/>
           </a:solidFill>
           <a:ln xmlns:a="http://schemas.openxmlformats.org/drawingml/2006/main" w="0">
             <a:noFill/>
@@ -5048,16 +5104,17 @@
           <a:lstStyle xmlns:a="http://schemas.openxmlformats.org/drawingml/2006/main"/>
           <a:p xmlns:a="http://schemas.openxmlformats.org/drawingml/2006/main">
             <a:pPr algn="l">
+              <a:buNone/>
               <a:defRPr sz="1200" b="1">
                 <a:solidFill>
-                  <a:srgbClr val="00A6A6"/>
+                  <a:srgbClr val="AA151B"/>
                 </a:solidFill>
               </a:defRPr>
             </a:pPr>
             <a:r>
               <a:rPr sz="1200" b="1">
                 <a:solidFill>
-                  <a:srgbClr val="00A6A6"/>
+                  <a:srgbClr val="AA151B"/>
                 </a:solidFill>
               </a:rPr>
               <a:t>01</a:t>
@@ -5098,16 +5155,17 @@
           <a:lstStyle xmlns:a="http://schemas.openxmlformats.org/drawingml/2006/main"/>
           <a:p xmlns:a="http://schemas.openxmlformats.org/drawingml/2006/main">
             <a:pPr algn="l">
+              <a:buNone/>
               <a:defRPr sz="2100" b="1">
                 <a:solidFill>
-                  <a:srgbClr val="0B1628"/>
+                  <a:srgbClr val="4A0B10"/>
                 </a:solidFill>
               </a:defRPr>
             </a:pPr>
             <a:r>
               <a:rPr sz="2100" b="1">
                 <a:solidFill>
-                  <a:srgbClr val="0B1628"/>
+                  <a:srgbClr val="4A0B10"/>
                 </a:solidFill>
               </a:rPr>
               <a:t>Model AI</a:t>
@@ -5148,16 +5206,17 @@
           <a:lstStyle xmlns:a="http://schemas.openxmlformats.org/drawingml/2006/main"/>
           <a:p xmlns:a="http://schemas.openxmlformats.org/drawingml/2006/main">
             <a:pPr algn="l">
+              <a:buNone/>
               <a:defRPr sz="1575" b="0">
                 <a:solidFill>
-                  <a:srgbClr val="536175"/>
+                  <a:srgbClr val="6F5550"/>
                 </a:solidFill>
               </a:defRPr>
             </a:pPr>
             <a:r>
               <a:rPr sz="1575" b="0">
                 <a:solidFill>
-                  <a:srgbClr val="536175"/>
+                  <a:srgbClr val="6F5550"/>
                 </a:solidFill>
               </a:rPr>
               <a:t>Memahami matlamat dan membuat pertimbangan.</a:t>
@@ -5188,7 +5247,7 @@
             <a:avLst/>
           </a:prstGeom>
           <a:solidFill xmlns:a="http://schemas.openxmlformats.org/drawingml/2006/main">
-            <a:srgbClr val="E5FBF8"/>
+            <a:srgbClr val="FFE59A"/>
           </a:solidFill>
           <a:ln xmlns:a="http://schemas.openxmlformats.org/drawingml/2006/main" w="0">
             <a:noFill/>
@@ -5229,16 +5288,17 @@
           <a:lstStyle xmlns:a="http://schemas.openxmlformats.org/drawingml/2006/main"/>
           <a:p xmlns:a="http://schemas.openxmlformats.org/drawingml/2006/main">
             <a:pPr algn="l">
+              <a:buNone/>
               <a:defRPr sz="1200" b="1">
                 <a:solidFill>
-                  <a:srgbClr val="00A6A6"/>
+                  <a:srgbClr val="AA151B"/>
                 </a:solidFill>
               </a:defRPr>
             </a:pPr>
             <a:r>
               <a:rPr sz="1200" b="1">
                 <a:solidFill>
-                  <a:srgbClr val="00A6A6"/>
+                  <a:srgbClr val="AA151B"/>
                 </a:solidFill>
               </a:rPr>
               <a:t>02</a:t>
@@ -5279,16 +5339,17 @@
           <a:lstStyle xmlns:a="http://schemas.openxmlformats.org/drawingml/2006/main"/>
           <a:p xmlns:a="http://schemas.openxmlformats.org/drawingml/2006/main">
             <a:pPr algn="l">
+              <a:buNone/>
               <a:defRPr sz="2100" b="1">
                 <a:solidFill>
-                  <a:srgbClr val="0B1628"/>
+                  <a:srgbClr val="4A0B10"/>
                 </a:solidFill>
               </a:defRPr>
             </a:pPr>
             <a:r>
               <a:rPr sz="2100" b="1">
                 <a:solidFill>
-                  <a:srgbClr val="0B1628"/>
+                  <a:srgbClr val="4A0B10"/>
                 </a:solidFill>
               </a:rPr>
               <a:t>Konteks</a:t>
@@ -5329,16 +5390,17 @@
           <a:lstStyle xmlns:a="http://schemas.openxmlformats.org/drawingml/2006/main"/>
           <a:p xmlns:a="http://schemas.openxmlformats.org/drawingml/2006/main">
             <a:pPr algn="l">
+              <a:buNone/>
               <a:defRPr sz="1575" b="0">
                 <a:solidFill>
-                  <a:srgbClr val="536175"/>
+                  <a:srgbClr val="6F5550"/>
                 </a:solidFill>
               </a:defRPr>
             </a:pPr>
             <a:r>
               <a:rPr sz="1575" b="0">
                 <a:solidFill>
-                  <a:srgbClr val="536175"/>
+                  <a:srgbClr val="6F5550"/>
                 </a:solidFill>
               </a:rPr>
               <a:t>Repositori, Google Drive, Docs, data dan arahan.</a:t>
@@ -5369,7 +5431,7 @@
             <a:avLst/>
           </a:prstGeom>
           <a:solidFill xmlns:a="http://schemas.openxmlformats.org/drawingml/2006/main">
-            <a:srgbClr val="0B1628"/>
+            <a:srgbClr val="4A0B10"/>
           </a:solidFill>
           <a:ln xmlns:a="http://schemas.openxmlformats.org/drawingml/2006/main" w="0">
             <a:noFill/>
@@ -5410,16 +5472,17 @@
           <a:lstStyle xmlns:a="http://schemas.openxmlformats.org/drawingml/2006/main"/>
           <a:p xmlns:a="http://schemas.openxmlformats.org/drawingml/2006/main">
             <a:pPr algn="l">
+              <a:buNone/>
               <a:defRPr sz="1200" b="1">
                 <a:solidFill>
-                  <a:srgbClr val="C8F135"/>
+                  <a:srgbClr val="F1BF00"/>
                 </a:solidFill>
               </a:defRPr>
             </a:pPr>
             <a:r>
               <a:rPr sz="1200" b="1">
                 <a:solidFill>
-                  <a:srgbClr val="C8F135"/>
+                  <a:srgbClr val="F1BF00"/>
                 </a:solidFill>
               </a:rPr>
               <a:t>03</a:t>
@@ -5460,16 +5523,17 @@
           <a:lstStyle xmlns:a="http://schemas.openxmlformats.org/drawingml/2006/main"/>
           <a:p xmlns:a="http://schemas.openxmlformats.org/drawingml/2006/main">
             <a:pPr algn="l">
+              <a:buNone/>
               <a:defRPr sz="2100" b="1">
                 <a:solidFill>
-                  <a:srgbClr val="FFFFFF"/>
+                  <a:srgbClr val="FFF8E7"/>
                 </a:solidFill>
               </a:defRPr>
             </a:pPr>
             <a:r>
               <a:rPr sz="2100" b="1">
                 <a:solidFill>
-                  <a:srgbClr val="FFFFFF"/>
+                  <a:srgbClr val="FFF8E7"/>
                 </a:solidFill>
               </a:rPr>
               <a:t>Alat</a:t>
@@ -5510,16 +5574,17 @@
           <a:lstStyle xmlns:a="http://schemas.openxmlformats.org/drawingml/2006/main"/>
           <a:p xmlns:a="http://schemas.openxmlformats.org/drawingml/2006/main">
             <a:pPr algn="l">
+              <a:buNone/>
               <a:defRPr sz="1575" b="0">
                 <a:solidFill>
-                  <a:srgbClr val="DCE4EE"/>
+                  <a:srgbClr val="F8E9D0"/>
                 </a:solidFill>
               </a:defRPr>
             </a:pPr>
             <a:r>
               <a:rPr sz="1575" b="0">
                 <a:solidFill>
-                  <a:srgbClr val="DCE4EE"/>
+                  <a:srgbClr val="F8E9D0"/>
                 </a:solidFill>
               </a:rPr>
               <a:t>Membaca, mengira, menulis, mencari dan menyusun.</a:t>
@@ -5552,7 +5617,7 @@
             </a:avLst>
           </a:prstGeom>
           <a:solidFill xmlns:a="http://schemas.openxmlformats.org/drawingml/2006/main">
-            <a:srgbClr val="C8F135"/>
+            <a:srgbClr val="F1BF00"/>
           </a:solidFill>
           <a:ln xmlns:a="http://schemas.openxmlformats.org/drawingml/2006/main" w="0">
             <a:noFill/>
@@ -5593,16 +5658,17 @@
           <a:lstStyle xmlns:a="http://schemas.openxmlformats.org/drawingml/2006/main"/>
           <a:p xmlns:a="http://schemas.openxmlformats.org/drawingml/2006/main">
             <a:pPr algn="ctr">
+              <a:buNone/>
               <a:defRPr sz="1350" b="1">
                 <a:solidFill>
-                  <a:srgbClr val="0B1628"/>
+                  <a:srgbClr val="4A0B10"/>
                 </a:solidFill>
               </a:defRPr>
             </a:pPr>
             <a:r>
               <a:rPr sz="1350" b="1">
                 <a:solidFill>
-                  <a:srgbClr val="0B1628"/>
+                  <a:srgbClr val="4A0B10"/>
                 </a:solidFill>
               </a:rPr>
               <a:t>Pengawasan manusia mengelilingi keseluruhan proses</a:t>
@@ -5626,7 +5692,7 @@
     <p:bg>
       <p:bgPr>
         <a:solidFill xmlns:a="http://schemas.openxmlformats.org/drawingml/2006/main">
-          <a:srgbClr val="FFFFFF"/>
+          <a:srgbClr val="FFF8E7"/>
         </a:solidFill>
       </p:bgPr>
     </p:bg>
@@ -5672,16 +5738,17 @@
           <a:lstStyle xmlns:a="http://schemas.openxmlformats.org/drawingml/2006/main"/>
           <a:p xmlns:a="http://schemas.openxmlformats.org/drawingml/2006/main">
             <a:pPr algn="l">
+              <a:buNone/>
               <a:defRPr sz="1050" b="1">
                 <a:solidFill>
-                  <a:srgbClr val="536175"/>
+                  <a:srgbClr val="6F5550"/>
                 </a:solidFill>
               </a:defRPr>
             </a:pPr>
             <a:r>
               <a:rPr sz="1050" b="1">
                 <a:solidFill>
-                  <a:srgbClr val="536175"/>
+                  <a:srgbClr val="6F5550"/>
                 </a:solidFill>
               </a:rPr>
               <a:t>ARAHAN YANG BERKESAN</a:t>
@@ -5722,16 +5789,17 @@
           <a:lstStyle xmlns:a="http://schemas.openxmlformats.org/drawingml/2006/main"/>
           <a:p xmlns:a="http://schemas.openxmlformats.org/drawingml/2006/main">
             <a:pPr algn="r">
+              <a:buNone/>
               <a:defRPr sz="1050" b="1">
                 <a:solidFill>
-                  <a:srgbClr val="536175"/>
+                  <a:srgbClr val="6F5550"/>
                 </a:solidFill>
               </a:defRPr>
             </a:pPr>
             <a:r>
               <a:rPr sz="1050" b="1">
                 <a:solidFill>
-                  <a:srgbClr val="536175"/>
+                  <a:srgbClr val="6F5550"/>
                 </a:solidFill>
               </a:rPr>
               <a:t>06</a:t>
@@ -5762,7 +5830,7 @@
             <a:avLst/>
           </a:prstGeom>
           <a:solidFill xmlns:a="http://schemas.openxmlformats.org/drawingml/2006/main">
-            <a:srgbClr val="C8D0DA"/>
+            <a:srgbClr val="D8BD75"/>
           </a:solidFill>
           <a:ln xmlns:a="http://schemas.openxmlformats.org/drawingml/2006/main" w="0">
             <a:noFill/>
@@ -5803,16 +5871,17 @@
           <a:lstStyle xmlns:a="http://schemas.openxmlformats.org/drawingml/2006/main"/>
           <a:p xmlns:a="http://schemas.openxmlformats.org/drawingml/2006/main">
             <a:pPr algn="l">
+              <a:buNone/>
               <a:defRPr sz="3150" b="1">
                 <a:solidFill>
-                  <a:srgbClr val="0B1628"/>
+                  <a:srgbClr val="4A0B10"/>
                 </a:solidFill>
               </a:defRPr>
             </a:pPr>
             <a:r>
               <a:rPr sz="3150" b="1">
                 <a:solidFill>
-                  <a:srgbClr val="0B1628"/>
+                  <a:srgbClr val="4A0B10"/>
                 </a:solidFill>
               </a:rPr>
               <a:t>Berikan agent sebuah tugasan lengkap—bukan sekadar prompt.</a:t>
@@ -5853,16 +5922,17 @@
           <a:lstStyle xmlns:a="http://schemas.openxmlformats.org/drawingml/2006/main"/>
           <a:p xmlns:a="http://schemas.openxmlformats.org/drawingml/2006/main">
             <a:pPr algn="l">
+              <a:buNone/>
               <a:defRPr sz="1200" b="1">
                 <a:solidFill>
-                  <a:srgbClr val="00A6A6"/>
+                  <a:srgbClr val="AA151B"/>
                 </a:solidFill>
               </a:defRPr>
             </a:pPr>
             <a:r>
               <a:rPr sz="1200" b="1">
                 <a:solidFill>
-                  <a:srgbClr val="00A6A6"/>
+                  <a:srgbClr val="AA151B"/>
                 </a:solidFill>
               </a:rPr>
               <a:t>01</a:t>
@@ -5903,16 +5973,17 @@
           <a:lstStyle xmlns:a="http://schemas.openxmlformats.org/drawingml/2006/main"/>
           <a:p xmlns:a="http://schemas.openxmlformats.org/drawingml/2006/main">
             <a:pPr algn="l">
+              <a:buNone/>
               <a:defRPr sz="1800" b="1">
                 <a:solidFill>
-                  <a:srgbClr val="0B1628"/>
+                  <a:srgbClr val="4A0B10"/>
                 </a:solidFill>
               </a:defRPr>
             </a:pPr>
             <a:r>
               <a:rPr sz="1800" b="1">
                 <a:solidFill>
-                  <a:srgbClr val="0B1628"/>
+                  <a:srgbClr val="4A0B10"/>
                 </a:solidFill>
               </a:rPr>
               <a:t>Matlamat</a:t>
@@ -5953,16 +6024,17 @@
           <a:lstStyle xmlns:a="http://schemas.openxmlformats.org/drawingml/2006/main"/>
           <a:p xmlns:a="http://schemas.openxmlformats.org/drawingml/2006/main">
             <a:pPr algn="l">
+              <a:buNone/>
               <a:defRPr sz="1575" b="0">
                 <a:solidFill>
-                  <a:srgbClr val="536175"/>
+                  <a:srgbClr val="6F5550"/>
                 </a:solidFill>
               </a:defRPr>
             </a:pPr>
             <a:r>
               <a:rPr sz="1575" b="0">
                 <a:solidFill>
-                  <a:srgbClr val="536175"/>
+                  <a:srgbClr val="6F5550"/>
                 </a:solidFill>
               </a:rPr>
               <a:t>Apa yang mahu dicapai?</a:t>
@@ -5993,7 +6065,7 @@
             <a:avLst/>
           </a:prstGeom>
           <a:solidFill xmlns:a="http://schemas.openxmlformats.org/drawingml/2006/main">
-            <a:srgbClr val="C8D0DA"/>
+            <a:srgbClr val="D8BD75"/>
           </a:solidFill>
           <a:ln xmlns:a="http://schemas.openxmlformats.org/drawingml/2006/main" w="0">
             <a:noFill/>
@@ -6034,16 +6106,17 @@
           <a:lstStyle xmlns:a="http://schemas.openxmlformats.org/drawingml/2006/main"/>
           <a:p xmlns:a="http://schemas.openxmlformats.org/drawingml/2006/main">
             <a:pPr algn="l">
+              <a:buNone/>
               <a:defRPr sz="1200" b="1">
                 <a:solidFill>
-                  <a:srgbClr val="00A6A6"/>
+                  <a:srgbClr val="AA151B"/>
                 </a:solidFill>
               </a:defRPr>
             </a:pPr>
             <a:r>
               <a:rPr sz="1200" b="1">
                 <a:solidFill>
-                  <a:srgbClr val="00A6A6"/>
+                  <a:srgbClr val="AA151B"/>
                 </a:solidFill>
               </a:rPr>
               <a:t>02</a:t>
@@ -6084,16 +6157,17 @@
           <a:lstStyle xmlns:a="http://schemas.openxmlformats.org/drawingml/2006/main"/>
           <a:p xmlns:a="http://schemas.openxmlformats.org/drawingml/2006/main">
             <a:pPr algn="l">
+              <a:buNone/>
               <a:defRPr sz="1800" b="1">
                 <a:solidFill>
-                  <a:srgbClr val="0B1628"/>
+                  <a:srgbClr val="4A0B10"/>
                 </a:solidFill>
               </a:defRPr>
             </a:pPr>
             <a:r>
               <a:rPr sz="1800" b="1">
                 <a:solidFill>
-                  <a:srgbClr val="0B1628"/>
+                  <a:srgbClr val="4A0B10"/>
                 </a:solidFill>
               </a:rPr>
               <a:t>Bahan</a:t>
@@ -6134,16 +6208,17 @@
           <a:lstStyle xmlns:a="http://schemas.openxmlformats.org/drawingml/2006/main"/>
           <a:p xmlns:a="http://schemas.openxmlformats.org/drawingml/2006/main">
             <a:pPr algn="l">
+              <a:buNone/>
               <a:defRPr sz="1575" b="0">
                 <a:solidFill>
-                  <a:srgbClr val="536175"/>
+                  <a:srgbClr val="6F5550"/>
                 </a:solidFill>
               </a:defRPr>
             </a:pPr>
             <a:r>
               <a:rPr sz="1575" b="0">
                 <a:solidFill>
-                  <a:srgbClr val="536175"/>
+                  <a:srgbClr val="6F5550"/>
                 </a:solidFill>
               </a:rPr>
               <a:t>Sumber mana boleh digunakan?</a:t>
@@ -6174,7 +6249,7 @@
             <a:avLst/>
           </a:prstGeom>
           <a:solidFill xmlns:a="http://schemas.openxmlformats.org/drawingml/2006/main">
-            <a:srgbClr val="C8D0DA"/>
+            <a:srgbClr val="D8BD75"/>
           </a:solidFill>
           <a:ln xmlns:a="http://schemas.openxmlformats.org/drawingml/2006/main" w="0">
             <a:noFill/>
@@ -6215,16 +6290,17 @@
           <a:lstStyle xmlns:a="http://schemas.openxmlformats.org/drawingml/2006/main"/>
           <a:p xmlns:a="http://schemas.openxmlformats.org/drawingml/2006/main">
             <a:pPr algn="l">
+              <a:buNone/>
               <a:defRPr sz="1200" b="1">
                 <a:solidFill>
-                  <a:srgbClr val="00A6A6"/>
+                  <a:srgbClr val="AA151B"/>
                 </a:solidFill>
               </a:defRPr>
             </a:pPr>
             <a:r>
               <a:rPr sz="1200" b="1">
                 <a:solidFill>
-                  <a:srgbClr val="00A6A6"/>
+                  <a:srgbClr val="AA151B"/>
                 </a:solidFill>
               </a:rPr>
               <a:t>03</a:t>
@@ -6265,16 +6341,17 @@
           <a:lstStyle xmlns:a="http://schemas.openxmlformats.org/drawingml/2006/main"/>
           <a:p xmlns:a="http://schemas.openxmlformats.org/drawingml/2006/main">
             <a:pPr algn="l">
+              <a:buNone/>
               <a:defRPr sz="1800" b="1">
                 <a:solidFill>
-                  <a:srgbClr val="0B1628"/>
+                  <a:srgbClr val="4A0B10"/>
                 </a:solidFill>
               </a:defRPr>
             </a:pPr>
             <a:r>
               <a:rPr sz="1800" b="1">
                 <a:solidFill>
-                  <a:srgbClr val="0B1628"/>
+                  <a:srgbClr val="4A0B10"/>
                 </a:solidFill>
               </a:rPr>
               <a:t>Batasan</a:t>
@@ -6315,16 +6392,17 @@
           <a:lstStyle xmlns:a="http://schemas.openxmlformats.org/drawingml/2006/main"/>
           <a:p xmlns:a="http://schemas.openxmlformats.org/drawingml/2006/main">
             <a:pPr algn="l">
+              <a:buNone/>
               <a:defRPr sz="1575" b="0">
                 <a:solidFill>
-                  <a:srgbClr val="536175"/>
+                  <a:srgbClr val="6F5550"/>
                 </a:solidFill>
               </a:defRPr>
             </a:pPr>
             <a:r>
               <a:rPr sz="1575" b="0">
                 <a:solidFill>
-                  <a:srgbClr val="536175"/>
+                  <a:srgbClr val="6F5550"/>
                 </a:solidFill>
               </a:rPr>
               <a:t>Apa yang tidak boleh dilakukan?</a:t>
@@ -6355,7 +6433,7 @@
             <a:avLst/>
           </a:prstGeom>
           <a:solidFill xmlns:a="http://schemas.openxmlformats.org/drawingml/2006/main">
-            <a:srgbClr val="C8D0DA"/>
+            <a:srgbClr val="D8BD75"/>
           </a:solidFill>
           <a:ln xmlns:a="http://schemas.openxmlformats.org/drawingml/2006/main" w="0">
             <a:noFill/>
@@ -6396,16 +6474,17 @@
           <a:lstStyle xmlns:a="http://schemas.openxmlformats.org/drawingml/2006/main"/>
           <a:p xmlns:a="http://schemas.openxmlformats.org/drawingml/2006/main">
             <a:pPr algn="l">
+              <a:buNone/>
               <a:defRPr sz="1200" b="1">
                 <a:solidFill>
-                  <a:srgbClr val="00A6A6"/>
+                  <a:srgbClr val="AA151B"/>
                 </a:solidFill>
               </a:defRPr>
             </a:pPr>
             <a:r>
               <a:rPr sz="1200" b="1">
                 <a:solidFill>
-                  <a:srgbClr val="00A6A6"/>
+                  <a:srgbClr val="AA151B"/>
                 </a:solidFill>
               </a:rPr>
               <a:t>04</a:t>
@@ -6446,16 +6525,17 @@
           <a:lstStyle xmlns:a="http://schemas.openxmlformats.org/drawingml/2006/main"/>
           <a:p xmlns:a="http://schemas.openxmlformats.org/drawingml/2006/main">
             <a:pPr algn="l">
+              <a:buNone/>
               <a:defRPr sz="1800" b="1">
                 <a:solidFill>
-                  <a:srgbClr val="0B1628"/>
+                  <a:srgbClr val="4A0B10"/>
                 </a:solidFill>
               </a:defRPr>
             </a:pPr>
             <a:r>
               <a:rPr sz="1800" b="1">
                 <a:solidFill>
-                  <a:srgbClr val="0B1628"/>
+                  <a:srgbClr val="4A0B10"/>
                 </a:solidFill>
               </a:rPr>
               <a:t>Hasil</a:t>
@@ -6496,16 +6576,17 @@
           <a:lstStyle xmlns:a="http://schemas.openxmlformats.org/drawingml/2006/main"/>
           <a:p xmlns:a="http://schemas.openxmlformats.org/drawingml/2006/main">
             <a:pPr algn="l">
+              <a:buNone/>
               <a:defRPr sz="1575" b="0">
                 <a:solidFill>
-                  <a:srgbClr val="536175"/>
+                  <a:srgbClr val="6F5550"/>
                 </a:solidFill>
               </a:defRPr>
             </a:pPr>
             <a:r>
               <a:rPr sz="1575" b="0">
                 <a:solidFill>
-                  <a:srgbClr val="536175"/>
+                  <a:srgbClr val="6F5550"/>
                 </a:solidFill>
               </a:rPr>
               <a:t>Format akhir apa diperlukan?</a:t>
@@ -6536,7 +6617,7 @@
             <a:avLst/>
           </a:prstGeom>
           <a:solidFill xmlns:a="http://schemas.openxmlformats.org/drawingml/2006/main">
-            <a:srgbClr val="C8D0DA"/>
+            <a:srgbClr val="D8BD75"/>
           </a:solidFill>
           <a:ln xmlns:a="http://schemas.openxmlformats.org/drawingml/2006/main" w="0">
             <a:noFill/>
@@ -6577,16 +6658,17 @@
           <a:lstStyle xmlns:a="http://schemas.openxmlformats.org/drawingml/2006/main"/>
           <a:p xmlns:a="http://schemas.openxmlformats.org/drawingml/2006/main">
             <a:pPr algn="l">
+              <a:buNone/>
               <a:defRPr sz="1200" b="1">
                 <a:solidFill>
-                  <a:srgbClr val="00A6A6"/>
+                  <a:srgbClr val="AA151B"/>
                 </a:solidFill>
               </a:defRPr>
             </a:pPr>
             <a:r>
               <a:rPr sz="1200" b="1">
                 <a:solidFill>
-                  <a:srgbClr val="00A6A6"/>
+                  <a:srgbClr val="AA151B"/>
                 </a:solidFill>
               </a:rPr>
               <a:t>05</a:t>
@@ -6627,16 +6709,17 @@
           <a:lstStyle xmlns:a="http://schemas.openxmlformats.org/drawingml/2006/main"/>
           <a:p xmlns:a="http://schemas.openxmlformats.org/drawingml/2006/main">
             <a:pPr algn="l">
+              <a:buNone/>
               <a:defRPr sz="1800" b="1">
                 <a:solidFill>
-                  <a:srgbClr val="0B1628"/>
+                  <a:srgbClr val="4A0B10"/>
                 </a:solidFill>
               </a:defRPr>
             </a:pPr>
             <a:r>
               <a:rPr sz="1800" b="1">
                 <a:solidFill>
-                  <a:srgbClr val="0B1628"/>
+                  <a:srgbClr val="4A0B10"/>
                 </a:solidFill>
               </a:rPr>
               <a:t>Semakan</a:t>
@@ -6677,16 +6760,17 @@
           <a:lstStyle xmlns:a="http://schemas.openxmlformats.org/drawingml/2006/main"/>
           <a:p xmlns:a="http://schemas.openxmlformats.org/drawingml/2006/main">
             <a:pPr algn="l">
+              <a:buNone/>
               <a:defRPr sz="1575" b="0">
                 <a:solidFill>
-                  <a:srgbClr val="536175"/>
+                  <a:srgbClr val="6F5550"/>
                 </a:solidFill>
               </a:defRPr>
             </a:pPr>
             <a:r>
               <a:rPr sz="1575" b="0">
                 <a:solidFill>
-                  <a:srgbClr val="536175"/>
+                  <a:srgbClr val="6F5550"/>
                 </a:solidFill>
               </a:rPr>
               <a:t>Apa yang mesti disahkan?</a:t>
@@ -6717,7 +6801,7 @@
             <a:avLst/>
           </a:prstGeom>
           <a:solidFill xmlns:a="http://schemas.openxmlformats.org/drawingml/2006/main">
-            <a:srgbClr val="0B1628"/>
+            <a:srgbClr val="4A0B10"/>
           </a:solidFill>
           <a:ln xmlns:a="http://schemas.openxmlformats.org/drawingml/2006/main" w="0">
             <a:noFill/>
@@ -6741,7 +6825,7 @@
     <p:bg>
       <p:bgPr>
         <a:solidFill xmlns:a="http://schemas.openxmlformats.org/drawingml/2006/main">
-          <a:srgbClr val="0B1628"/>
+          <a:srgbClr val="4A0B10"/>
         </a:solidFill>
       </p:bgPr>
     </p:bg>
@@ -6787,16 +6871,17 @@
           <a:lstStyle xmlns:a="http://schemas.openxmlformats.org/drawingml/2006/main"/>
           <a:p xmlns:a="http://schemas.openxmlformats.org/drawingml/2006/main">
             <a:pPr algn="l">
+              <a:buNone/>
               <a:defRPr sz="1125" b="1">
                 <a:solidFill>
-                  <a:srgbClr val="C8F135"/>
+                  <a:srgbClr val="F1BF00"/>
                 </a:solidFill>
               </a:defRPr>
             </a:pPr>
             <a:r>
               <a:rPr sz="1125" b="1">
                 <a:solidFill>
-                  <a:srgbClr val="C8F135"/>
+                  <a:srgbClr val="F1BF00"/>
                 </a:solidFill>
               </a:rPr>
               <a:t>SEBELUM KITA DEMONSTRASIKAN</a:t>
@@ -6837,16 +6922,17 @@
           <a:lstStyle xmlns:a="http://schemas.openxmlformats.org/drawingml/2006/main"/>
           <a:p xmlns:a="http://schemas.openxmlformats.org/drawingml/2006/main">
             <a:pPr algn="l">
+              <a:buNone/>
               <a:defRPr sz="3300" b="1">
                 <a:solidFill>
-                  <a:srgbClr val="FFFFFF"/>
+                  <a:srgbClr val="FFF8E7"/>
                 </a:solidFill>
               </a:defRPr>
             </a:pPr>
             <a:r>
               <a:rPr sz="3300" b="1">
                 <a:solidFill>
-                  <a:srgbClr val="FFFFFF"/>
+                  <a:srgbClr val="FFF8E7"/>
                 </a:solidFill>
               </a:rPr>
               <a:t>Agentic tidak bermaksud</a:t>
@@ -6854,16 +6940,17 @@
           </a:p>
           <a:p xmlns:a="http://schemas.openxmlformats.org/drawingml/2006/main">
             <a:pPr algn="l">
+              <a:buNone/>
               <a:defRPr sz="3300" b="1">
                 <a:solidFill>
-                  <a:srgbClr val="FFFFFF"/>
+                  <a:srgbClr val="FFF8E7"/>
                 </a:solidFill>
               </a:defRPr>
             </a:pPr>
             <a:r>
               <a:rPr sz="3300" b="1">
                 <a:solidFill>
-                  <a:srgbClr val="FFFFFF"/>
+                  <a:srgbClr val="FFF8E7"/>
                 </a:solidFill>
               </a:rPr>
               <a:t>autonomi tanpa kawalan.</a:t>
@@ -6894,7 +6981,7 @@
             <a:avLst/>
           </a:prstGeom>
           <a:solidFill xmlns:a="http://schemas.openxmlformats.org/drawingml/2006/main">
-            <a:srgbClr val="C8F135"/>
+            <a:srgbClr val="F1BF00"/>
           </a:solidFill>
           <a:ln xmlns:a="http://schemas.openxmlformats.org/drawingml/2006/main" w="0">
             <a:noFill/>
@@ -6935,16 +7022,17 @@
           <a:lstStyle xmlns:a="http://schemas.openxmlformats.org/drawingml/2006/main"/>
           <a:p xmlns:a="http://schemas.openxmlformats.org/drawingml/2006/main">
             <a:pPr algn="l">
+              <a:buNone/>
               <a:defRPr sz="1200" b="1">
                 <a:solidFill>
-                  <a:srgbClr val="C8F135"/>
+                  <a:srgbClr val="F1BF00"/>
                 </a:solidFill>
               </a:defRPr>
             </a:pPr>
             <a:r>
               <a:rPr sz="1200" b="1">
                 <a:solidFill>
-                  <a:srgbClr val="C8F135"/>
+                  <a:srgbClr val="F1BF00"/>
                 </a:solidFill>
               </a:rPr>
               <a:t>01</a:t>
@@ -6985,16 +7073,17 @@
           <a:lstStyle xmlns:a="http://schemas.openxmlformats.org/drawingml/2006/main"/>
           <a:p xmlns:a="http://schemas.openxmlformats.org/drawingml/2006/main">
             <a:pPr algn="l">
+              <a:buNone/>
               <a:defRPr sz="1875" b="1">
                 <a:solidFill>
-                  <a:srgbClr val="FFFFFF"/>
+                  <a:srgbClr val="FFF8E7"/>
                 </a:solidFill>
               </a:defRPr>
             </a:pPr>
             <a:r>
               <a:rPr sz="1875" b="1">
                 <a:solidFill>
-                  <a:srgbClr val="FFFFFF"/>
+                  <a:srgbClr val="FFF8E7"/>
                 </a:solidFill>
               </a:rPr>
               <a:t>Akses minimum</a:t>
@@ -7035,16 +7124,17 @@
           <a:lstStyle xmlns:a="http://schemas.openxmlformats.org/drawingml/2006/main"/>
           <a:p xmlns:a="http://schemas.openxmlformats.org/drawingml/2006/main">
             <a:pPr algn="l">
+              <a:buNone/>
               <a:defRPr sz="1500" b="0">
                 <a:solidFill>
-                  <a:srgbClr val="DCE4EE"/>
+                  <a:srgbClr val="F8E9D0"/>
                 </a:solidFill>
               </a:defRPr>
             </a:pPr>
             <a:r>
               <a:rPr sz="1500" b="0">
                 <a:solidFill>
-                  <a:srgbClr val="DCE4EE"/>
+                  <a:srgbClr val="F8E9D0"/>
                 </a:solidFill>
               </a:rPr>
               <a:t>Beri hanya fail dan aplikasi yang diperlukan.</a:t>
@@ -7075,7 +7165,7 @@
             <a:avLst/>
           </a:prstGeom>
           <a:solidFill xmlns:a="http://schemas.openxmlformats.org/drawingml/2006/main">
-            <a:srgbClr val="00A6A6"/>
+            <a:srgbClr val="AA151B"/>
           </a:solidFill>
           <a:ln xmlns:a="http://schemas.openxmlformats.org/drawingml/2006/main" w="0">
             <a:noFill/>
@@ -7116,16 +7206,17 @@
           <a:lstStyle xmlns:a="http://schemas.openxmlformats.org/drawingml/2006/main"/>
           <a:p xmlns:a="http://schemas.openxmlformats.org/drawingml/2006/main">
             <a:pPr algn="l">
+              <a:buNone/>
               <a:defRPr sz="1200" b="1">
                 <a:solidFill>
-                  <a:srgbClr val="C8F135"/>
+                  <a:srgbClr val="F1BF00"/>
                 </a:solidFill>
               </a:defRPr>
             </a:pPr>
             <a:r>
               <a:rPr sz="1200" b="1">
                 <a:solidFill>
-                  <a:srgbClr val="C8F135"/>
+                  <a:srgbClr val="F1BF00"/>
                 </a:solidFill>
               </a:rPr>
               <a:t>02</a:t>
@@ -7166,16 +7257,17 @@
           <a:lstStyle xmlns:a="http://schemas.openxmlformats.org/drawingml/2006/main"/>
           <a:p xmlns:a="http://schemas.openxmlformats.org/drawingml/2006/main">
             <a:pPr algn="l">
+              <a:buNone/>
               <a:defRPr sz="1875" b="1">
                 <a:solidFill>
-                  <a:srgbClr val="FFFFFF"/>
+                  <a:srgbClr val="FFF8E7"/>
                 </a:solidFill>
               </a:defRPr>
             </a:pPr>
             <a:r>
               <a:rPr sz="1875" b="1">
                 <a:solidFill>
-                  <a:srgbClr val="FFFFFF"/>
+                  <a:srgbClr val="FFF8E7"/>
                 </a:solidFill>
               </a:rPr>
               <a:t>Semak sebelum guna</a:t>
@@ -7216,16 +7308,17 @@
           <a:lstStyle xmlns:a="http://schemas.openxmlformats.org/drawingml/2006/main"/>
           <a:p xmlns:a="http://schemas.openxmlformats.org/drawingml/2006/main">
             <a:pPr algn="l">
+              <a:buNone/>
               <a:defRPr sz="1500" b="0">
                 <a:solidFill>
-                  <a:srgbClr val="DCE4EE"/>
+                  <a:srgbClr val="F8E9D0"/>
                 </a:solidFill>
               </a:defRPr>
             </a:pPr>
             <a:r>
               <a:rPr sz="1500" b="0">
                 <a:solidFill>
-                  <a:srgbClr val="DCE4EE"/>
+                  <a:srgbClr val="F8E9D0"/>
                 </a:solidFill>
               </a:rPr>
               <a:t>Periksa fakta, angka, penerima dan lampiran.</a:t>
@@ -7256,7 +7349,7 @@
             <a:avLst/>
           </a:prstGeom>
           <a:solidFill xmlns:a="http://schemas.openxmlformats.org/drawingml/2006/main">
-            <a:srgbClr val="00A6A6"/>
+            <a:srgbClr val="AA151B"/>
           </a:solidFill>
           <a:ln xmlns:a="http://schemas.openxmlformats.org/drawingml/2006/main" w="0">
             <a:noFill/>
@@ -7297,16 +7390,17 @@
           <a:lstStyle xmlns:a="http://schemas.openxmlformats.org/drawingml/2006/main"/>
           <a:p xmlns:a="http://schemas.openxmlformats.org/drawingml/2006/main">
             <a:pPr algn="l">
+              <a:buNone/>
               <a:defRPr sz="1200" b="1">
                 <a:solidFill>
-                  <a:srgbClr val="C8F135"/>
+                  <a:srgbClr val="F1BF00"/>
                 </a:solidFill>
               </a:defRPr>
             </a:pPr>
             <a:r>
               <a:rPr sz="1200" b="1">
                 <a:solidFill>
-                  <a:srgbClr val="C8F135"/>
+                  <a:srgbClr val="F1BF00"/>
                 </a:solidFill>
               </a:rPr>
               <a:t>03</a:t>
@@ -7347,16 +7441,17 @@
           <a:lstStyle xmlns:a="http://schemas.openxmlformats.org/drawingml/2006/main"/>
           <a:p xmlns:a="http://schemas.openxmlformats.org/drawingml/2006/main">
             <a:pPr algn="l">
+              <a:buNone/>
               <a:defRPr sz="1875" b="1">
                 <a:solidFill>
-                  <a:srgbClr val="FFFFFF"/>
+                  <a:srgbClr val="FFF8E7"/>
                 </a:solidFill>
               </a:defRPr>
             </a:pPr>
             <a:r>
               <a:rPr sz="1875" b="1">
                 <a:solidFill>
-                  <a:srgbClr val="FFFFFF"/>
+                  <a:srgbClr val="FFF8E7"/>
                 </a:solidFill>
               </a:rPr>
               <a:t>Manusia meluluskan</a:t>
@@ -7397,16 +7492,17 @@
           <a:lstStyle xmlns:a="http://schemas.openxmlformats.org/drawingml/2006/main"/>
           <a:p xmlns:a="http://schemas.openxmlformats.org/drawingml/2006/main">
             <a:pPr algn="l">
+              <a:buNone/>
               <a:defRPr sz="1500" b="0">
                 <a:solidFill>
-                  <a:srgbClr val="DCE4EE"/>
+                  <a:srgbClr val="F8E9D0"/>
                 </a:solidFill>
               </a:defRPr>
             </a:pPr>
             <a:r>
               <a:rPr sz="1500" b="0">
                 <a:solidFill>
-                  <a:srgbClr val="DCE4EE"/>
+                  <a:srgbClr val="F8E9D0"/>
                 </a:solidFill>
               </a:rPr>
               <a:t>Kekalkan kawalan bagi tindakan rasmi dan berimpak tinggi.</a:t>
@@ -7447,16 +7543,17 @@
           <a:lstStyle xmlns:a="http://schemas.openxmlformats.org/drawingml/2006/main"/>
           <a:p xmlns:a="http://schemas.openxmlformats.org/drawingml/2006/main">
             <a:pPr algn="l">
+              <a:buNone/>
               <a:defRPr sz="1425" b="1">
                 <a:solidFill>
-                  <a:srgbClr val="FFFFFF"/>
+                  <a:srgbClr val="FFF8E7"/>
                 </a:solidFill>
               </a:defRPr>
             </a:pPr>
             <a:r>
               <a:rPr sz="1425" b="1">
                 <a:solidFill>
-                  <a:srgbClr val="FFFFFF"/>
+                  <a:srgbClr val="FFF8E7"/>
                 </a:solidFill>
               </a:rPr>
               <a:t>Seterusnya: Gemini → Codex → Claude Cowork</a:t>
@@ -7479,40 +7576,40 @@
   <a:themeElements>
     <a:clrScheme name="ChatGPT">
       <a:dk1>
-        <a:srgbClr val="000000"/>
+        <a:srgbClr val="2C070A"/>
       </a:dk1>
       <a:lt1>
-        <a:srgbClr val="FFFFFF"/>
+        <a:srgbClr val="FFF8E7"/>
       </a:lt1>
       <a:dk2>
-        <a:srgbClr val="0E2841"/>
+        <a:srgbClr val="4A0B10"/>
       </a:dk2>
       <a:lt2>
-        <a:srgbClr val="E8E8E8"/>
+        <a:srgbClr val="F4E4B4"/>
       </a:lt2>
       <a:accent1>
-        <a:srgbClr val="156082"/>
+        <a:srgbClr val="AA151B"/>
       </a:accent1>
       <a:accent2>
-        <a:srgbClr val="E97132"/>
+        <a:srgbClr val="F1BF00"/>
       </a:accent2>
       <a:accent3>
-        <a:srgbClr val="196B24"/>
+        <a:srgbClr val="7E1418"/>
       </a:accent3>
       <a:accent4>
-        <a:srgbClr val="0F9ED5"/>
+        <a:srgbClr val="C62828"/>
       </a:accent4>
       <a:accent5>
-        <a:srgbClr val="A02B93"/>
+        <a:srgbClr val="8A1C24"/>
       </a:accent5>
       <a:accent6>
-        <a:srgbClr val="4EA72E"/>
+        <a:srgbClr val="D89E00"/>
       </a:accent6>
       <a:hlink>
-        <a:srgbClr val="467886"/>
+        <a:srgbClr val="AA151B"/>
       </a:hlink>
       <a:folHlink>
-        <a:srgbClr val="96607D"/>
+        <a:srgbClr val="8A1C24"/>
       </a:folHlink>
     </a:clrScheme>
     <a:fontScheme name="Office">
@@ -7615,7 +7712,7 @@
         <a:effectStyle>
           <a:effectLst>
             <a:outerShdw blurRad="57150" dist="19050" dir="5400000">
-              <a:srgbClr val="000000">
+              <a:srgbClr val="2C070A">
                 <a:alpha val="16000"/>
               </a:srgbClr>
             </a:outerShdw>
@@ -7624,7 +7721,7 @@
         <a:effectStyle>
           <a:effectLst>
             <a:outerShdw blurRad="19050" dist="9525" dir="5400000">
-              <a:srgbClr val="000000">
+              <a:srgbClr val="2C070A">
                 <a:alpha val="6000"/>
               </a:srgbClr>
             </a:outerShdw>
@@ -7633,7 +7730,7 @@
         <a:effectStyle>
           <a:effectLst>
             <a:outerShdw blurRad="28575" dist="9525" dir="5400000">
-              <a:srgbClr val="000000">
+              <a:srgbClr val="2C070A">
                 <a:alpha val="8000"/>
               </a:srgbClr>
             </a:outerShdw>
@@ -7642,7 +7739,7 @@
         <a:effectStyle>
           <a:effectLst>
             <a:outerShdw blurRad="57150" dist="19050" dir="5400000">
-              <a:srgbClr val="000000">
+              <a:srgbClr val="2C070A">
                 <a:alpha val="10000"/>
               </a:srgbClr>
             </a:outerShdw>
@@ -7651,7 +7748,7 @@
         <a:effectStyle>
           <a:effectLst>
             <a:outerShdw blurRad="114300" dist="38100" dir="5400000">
-              <a:srgbClr val="000000">
+              <a:srgbClr val="2C070A">
                 <a:alpha val="12000"/>
               </a:srgbClr>
             </a:outerShdw>
@@ -7660,7 +7757,7 @@
         <a:effectStyle>
           <a:effectLst>
             <a:outerShdw blurRad="171450" dist="57150" dir="5400000">
-              <a:srgbClr val="000000">
+              <a:srgbClr val="2C070A">
                 <a:alpha val="16000"/>
               </a:srgbClr>
             </a:outerShdw>
@@ -7669,7 +7766,7 @@
         <a:effectStyle>
           <a:effectLst>
             <a:outerShdw blurRad="266700" dist="95250" dir="5400000">
-              <a:srgbClr val="000000">
+              <a:srgbClr val="2C070A">
                 <a:alpha val="24000"/>
               </a:srgbClr>
             </a:outerShdw>

</xml_diff>